<commit_message>
esame: presentazione 20 slide senza numeri di pagina, rimosso ppt_build
</commit_message>
<xml_diff>
--- a/esame/Project16_Presentazione.pptx
+++ b/esame/Project16_Presentazione.pptx
@@ -5,7 +5,7 @@
     <p:sldMasterId id="2147483648" r:id="rId1"/>
   </p:sldMasterIdLst>
   <p:notesMasterIdLst>
-    <p:notesMasterId r:id="rId19"/>
+    <p:notesMasterId r:id="rId22"/>
   </p:notesMasterIdLst>
   <p:sldIdLst>
     <p:sldId id="256" r:id="rId2"/>
@@ -22,9 +22,12 @@
     <p:sldId id="268" r:id="rId13"/>
     <p:sldId id="269" r:id="rId14"/>
     <p:sldId id="270" r:id="rId15"/>
-    <p:sldId id="272" r:id="rId16"/>
-    <p:sldId id="273" r:id="rId17"/>
-    <p:sldId id="275" r:id="rId18"/>
+    <p:sldId id="277" r:id="rId16"/>
+    <p:sldId id="281" r:id="rId17"/>
+    <p:sldId id="282" r:id="rId18"/>
+    <p:sldId id="272" r:id="rId19"/>
+    <p:sldId id="273" r:id="rId20"/>
+    <p:sldId id="275" r:id="rId21"/>
   </p:sldIdLst>
   <p:sldSz cx="12192000" cy="6858000"/>
   <p:notesSz cx="6858000" cy="12192000"/>
@@ -1163,7 +1166,13 @@
   <p:cSld>
     <p:spTree>
       <p:nvGrpSpPr>
-        <p:cNvPr id="1" name=""/>
+        <p:cNvPr id="1" name="">
+          <a:extLst>
+            <a:ext uri="{FF2B5EF4-FFF2-40B4-BE49-F238E27FC236}">
+              <a16:creationId xmlns:a16="http://schemas.microsoft.com/office/drawing/2014/main" id="{D2316731-0F31-8E17-7250-80C27AF714AE}"/>
+            </a:ext>
+          </a:extLst>
+        </p:cNvPr>
         <p:cNvGrpSpPr/>
         <p:nvPr/>
       </p:nvGrpSpPr>
@@ -1177,7 +1186,13 @@
       </p:grpSpPr>
       <p:sp>
         <p:nvSpPr>
-          <p:cNvPr id="2" name="Slide Image Placeholder 1"/>
+          <p:cNvPr id="2" name="Slide Image Placeholder 1">
+            <a:extLst>
+              <a:ext uri="{FF2B5EF4-FFF2-40B4-BE49-F238E27FC236}">
+                <a16:creationId xmlns:a16="http://schemas.microsoft.com/office/drawing/2014/main" id="{A41E20F5-DE36-00EC-1CA2-F80DB5CCD694}"/>
+              </a:ext>
+            </a:extLst>
+          </p:cNvPr>
           <p:cNvSpPr>
             <a:spLocks noGrp="1" noRot="1" noChangeAspect="1"/>
           </p:cNvSpPr>
@@ -1189,7 +1204,13 @@
       </p:sp>
       <p:sp>
         <p:nvSpPr>
-          <p:cNvPr id="3" name="Notes Placeholder 2"/>
+          <p:cNvPr id="3" name="Notes Placeholder 2">
+            <a:extLst>
+              <a:ext uri="{FF2B5EF4-FFF2-40B4-BE49-F238E27FC236}">
+                <a16:creationId xmlns:a16="http://schemas.microsoft.com/office/drawing/2014/main" id="{135034BB-7536-D56B-54D5-A11BD0D0E5DA}"/>
+              </a:ext>
+            </a:extLst>
+          </p:cNvPr>
           <p:cNvSpPr>
             <a:spLocks noGrp="1"/>
           </p:cNvSpPr>
@@ -1208,7 +1229,13 @@
       </p:sp>
       <p:sp>
         <p:nvSpPr>
-          <p:cNvPr id="4" name="Slide Number Placeholder 3"/>
+          <p:cNvPr id="4" name="Slide Number Placeholder 3">
+            <a:extLst>
+              <a:ext uri="{FF2B5EF4-FFF2-40B4-BE49-F238E27FC236}">
+                <a16:creationId xmlns:a16="http://schemas.microsoft.com/office/drawing/2014/main" id="{C863BE16-192A-867B-5163-E382D1B50C25}"/>
+              </a:ext>
+            </a:extLst>
+          </p:cNvPr>
           <p:cNvSpPr>
             <a:spLocks noGrp="1"/>
           </p:cNvSpPr>
@@ -1232,7 +1259,7 @@
     </p:spTree>
     <p:extLst>
       <p:ext uri="{BB962C8B-B14F-4D97-AF65-F5344CB8AC3E}">
-        <p14:creationId xmlns:p14="http://schemas.microsoft.com/office/powerpoint/2010/main" val="1024086991"/>
+        <p14:creationId xmlns:p14="http://schemas.microsoft.com/office/powerpoint/2010/main" val="299563278"/>
       </p:ext>
     </p:extLst>
   </p:cSld>
@@ -1243,6 +1270,222 @@
 </file>
 
 <file path=ppt/notesSlides/notesSlide16.xml><?xml version="1.0" encoding="utf-8"?>
+<p:notes xmlns:a="http://schemas.openxmlformats.org/drawingml/2006/main" xmlns:r="http://schemas.openxmlformats.org/officeDocument/2006/relationships" xmlns:p="http://schemas.openxmlformats.org/presentationml/2006/main">
+  <p:cSld>
+    <p:spTree>
+      <p:nvGrpSpPr>
+        <p:cNvPr id="1" name="">
+          <a:extLst>
+            <a:ext uri="{FF2B5EF4-FFF2-40B4-BE49-F238E27FC236}">
+              <a16:creationId xmlns:a16="http://schemas.microsoft.com/office/drawing/2014/main" id="{73D8E446-711F-7057-9421-564AFDAD828B}"/>
+            </a:ext>
+          </a:extLst>
+        </p:cNvPr>
+        <p:cNvGrpSpPr/>
+        <p:nvPr/>
+      </p:nvGrpSpPr>
+      <p:grpSpPr>
+        <a:xfrm>
+          <a:off x="0" y="0"/>
+          <a:ext cx="0" cy="0"/>
+          <a:chOff x="0" y="0"/>
+          <a:chExt cx="0" cy="0"/>
+        </a:xfrm>
+      </p:grpSpPr>
+      <p:sp>
+        <p:nvSpPr>
+          <p:cNvPr id="2" name="Slide Image Placeholder 1">
+            <a:extLst>
+              <a:ext uri="{FF2B5EF4-FFF2-40B4-BE49-F238E27FC236}">
+                <a16:creationId xmlns:a16="http://schemas.microsoft.com/office/drawing/2014/main" id="{825129E3-F142-D9EB-6D4E-80C9552EF1D5}"/>
+              </a:ext>
+            </a:extLst>
+          </p:cNvPr>
+          <p:cNvSpPr>
+            <a:spLocks noGrp="1" noRot="1" noChangeAspect="1"/>
+          </p:cNvSpPr>
+          <p:nvPr>
+            <p:ph type="sldImg"/>
+          </p:nvPr>
+        </p:nvSpPr>
+        <p:spPr/>
+      </p:sp>
+      <p:sp>
+        <p:nvSpPr>
+          <p:cNvPr id="3" name="Notes Placeholder 2">
+            <a:extLst>
+              <a:ext uri="{FF2B5EF4-FFF2-40B4-BE49-F238E27FC236}">
+                <a16:creationId xmlns:a16="http://schemas.microsoft.com/office/drawing/2014/main" id="{4E266A29-A9B0-AE6D-AB03-06620B022460}"/>
+              </a:ext>
+            </a:extLst>
+          </p:cNvPr>
+          <p:cNvSpPr>
+            <a:spLocks noGrp="1"/>
+          </p:cNvSpPr>
+          <p:nvPr>
+            <p:ph type="body" idx="1"/>
+          </p:nvPr>
+        </p:nvSpPr>
+        <p:spPr/>
+        <p:txBody>
+          <a:bodyPr/>
+          <a:lstStyle/>
+          <a:p>
+            <a:endParaRPr lang="en-US" dirty="0"/>
+          </a:p>
+        </p:txBody>
+      </p:sp>
+      <p:sp>
+        <p:nvSpPr>
+          <p:cNvPr id="4" name="Slide Number Placeholder 3">
+            <a:extLst>
+              <a:ext uri="{FF2B5EF4-FFF2-40B4-BE49-F238E27FC236}">
+                <a16:creationId xmlns:a16="http://schemas.microsoft.com/office/drawing/2014/main" id="{47D67621-CCBA-F5F0-1CCB-785F75A8BE7E}"/>
+              </a:ext>
+            </a:extLst>
+          </p:cNvPr>
+          <p:cNvSpPr>
+            <a:spLocks noGrp="1"/>
+          </p:cNvSpPr>
+          <p:nvPr>
+            <p:ph type="sldNum" sz="quarter" idx="10"/>
+          </p:nvPr>
+        </p:nvSpPr>
+        <p:spPr/>
+        <p:txBody>
+          <a:bodyPr/>
+          <a:lstStyle/>
+          <a:p>
+            <a:fld id="{F7021451-1387-4CA6-816F-3879F97B5CBC}" type="slidenum">
+              <a:rPr lang="en-US"/>
+              <a:t>16</a:t>
+            </a:fld>
+            <a:endParaRPr lang="en-US"/>
+          </a:p>
+        </p:txBody>
+      </p:sp>
+    </p:spTree>
+    <p:extLst>
+      <p:ext uri="{BB962C8B-B14F-4D97-AF65-F5344CB8AC3E}">
+        <p14:creationId xmlns:p14="http://schemas.microsoft.com/office/powerpoint/2010/main" val="1740252840"/>
+      </p:ext>
+    </p:extLst>
+  </p:cSld>
+  <p:clrMapOvr>
+    <a:masterClrMapping/>
+  </p:clrMapOvr>
+</p:notes>
+</file>
+
+<file path=ppt/notesSlides/notesSlide17.xml><?xml version="1.0" encoding="utf-8"?>
+<p:notes xmlns:a="http://schemas.openxmlformats.org/drawingml/2006/main" xmlns:r="http://schemas.openxmlformats.org/officeDocument/2006/relationships" xmlns:p="http://schemas.openxmlformats.org/presentationml/2006/main">
+  <p:cSld>
+    <p:spTree>
+      <p:nvGrpSpPr>
+        <p:cNvPr id="1" name="">
+          <a:extLst>
+            <a:ext uri="{FF2B5EF4-FFF2-40B4-BE49-F238E27FC236}">
+              <a16:creationId xmlns:a16="http://schemas.microsoft.com/office/drawing/2014/main" id="{BA107DB7-5F52-6A48-A956-448A729E8794}"/>
+            </a:ext>
+          </a:extLst>
+        </p:cNvPr>
+        <p:cNvGrpSpPr/>
+        <p:nvPr/>
+      </p:nvGrpSpPr>
+      <p:grpSpPr>
+        <a:xfrm>
+          <a:off x="0" y="0"/>
+          <a:ext cx="0" cy="0"/>
+          <a:chOff x="0" y="0"/>
+          <a:chExt cx="0" cy="0"/>
+        </a:xfrm>
+      </p:grpSpPr>
+      <p:sp>
+        <p:nvSpPr>
+          <p:cNvPr id="2" name="Slide Image Placeholder 1">
+            <a:extLst>
+              <a:ext uri="{FF2B5EF4-FFF2-40B4-BE49-F238E27FC236}">
+                <a16:creationId xmlns:a16="http://schemas.microsoft.com/office/drawing/2014/main" id="{809312F8-A68E-F47F-D2E0-914A84FBB827}"/>
+              </a:ext>
+            </a:extLst>
+          </p:cNvPr>
+          <p:cNvSpPr>
+            <a:spLocks noGrp="1" noRot="1" noChangeAspect="1"/>
+          </p:cNvSpPr>
+          <p:nvPr>
+            <p:ph type="sldImg"/>
+          </p:nvPr>
+        </p:nvSpPr>
+        <p:spPr/>
+      </p:sp>
+      <p:sp>
+        <p:nvSpPr>
+          <p:cNvPr id="3" name="Notes Placeholder 2">
+            <a:extLst>
+              <a:ext uri="{FF2B5EF4-FFF2-40B4-BE49-F238E27FC236}">
+                <a16:creationId xmlns:a16="http://schemas.microsoft.com/office/drawing/2014/main" id="{7BA0A9EB-D7D9-BD7E-7581-193FA88F084B}"/>
+              </a:ext>
+            </a:extLst>
+          </p:cNvPr>
+          <p:cNvSpPr>
+            <a:spLocks noGrp="1"/>
+          </p:cNvSpPr>
+          <p:nvPr>
+            <p:ph type="body" idx="1"/>
+          </p:nvPr>
+        </p:nvSpPr>
+        <p:spPr/>
+        <p:txBody>
+          <a:bodyPr/>
+          <a:lstStyle/>
+          <a:p>
+            <a:endParaRPr lang="en-US" dirty="0"/>
+          </a:p>
+        </p:txBody>
+      </p:sp>
+      <p:sp>
+        <p:nvSpPr>
+          <p:cNvPr id="4" name="Slide Number Placeholder 3">
+            <a:extLst>
+              <a:ext uri="{FF2B5EF4-FFF2-40B4-BE49-F238E27FC236}">
+                <a16:creationId xmlns:a16="http://schemas.microsoft.com/office/drawing/2014/main" id="{ADF5FA77-4186-3162-2E36-2B5AE60F92DA}"/>
+              </a:ext>
+            </a:extLst>
+          </p:cNvPr>
+          <p:cNvSpPr>
+            <a:spLocks noGrp="1"/>
+          </p:cNvSpPr>
+          <p:nvPr>
+            <p:ph type="sldNum" sz="quarter" idx="10"/>
+          </p:nvPr>
+        </p:nvSpPr>
+        <p:spPr/>
+        <p:txBody>
+          <a:bodyPr/>
+          <a:lstStyle/>
+          <a:p>
+            <a:fld id="{F7021451-1387-4CA6-816F-3879F97B5CBC}" type="slidenum">
+              <a:rPr lang="en-US"/>
+              <a:t>17</a:t>
+            </a:fld>
+            <a:endParaRPr lang="en-US"/>
+          </a:p>
+        </p:txBody>
+      </p:sp>
+    </p:spTree>
+    <p:extLst>
+      <p:ext uri="{BB962C8B-B14F-4D97-AF65-F5344CB8AC3E}">
+        <p14:creationId xmlns:p14="http://schemas.microsoft.com/office/powerpoint/2010/main" val="3857418714"/>
+      </p:ext>
+    </p:extLst>
+  </p:cSld>
+  <p:clrMapOvr>
+    <a:masterClrMapping/>
+  </p:clrMapOvr>
+</p:notes>
+</file>
+
+<file path=ppt/notesSlides/notesSlide18.xml><?xml version="1.0" encoding="utf-8"?>
 <p:notes xmlns:a="http://schemas.openxmlformats.org/drawingml/2006/main" xmlns:r="http://schemas.openxmlformats.org/officeDocument/2006/relationships" xmlns:p="http://schemas.openxmlformats.org/presentationml/2006/main">
   <p:cSld>
     <p:spTree>
@@ -1307,7 +1550,7 @@
           <a:p>
             <a:fld id="{F7021451-1387-4CA6-816F-3879F97B5CBC}" type="slidenum">
               <a:rPr lang="en-US"/>
-              <a:t>16</a:t>
+              <a:t>18</a:t>
             </a:fld>
             <a:endParaRPr lang="en-US"/>
           </a:p>
@@ -1326,7 +1569,7 @@
 </p:notes>
 </file>
 
-<file path=ppt/notesSlides/notesSlide17.xml><?xml version="1.0" encoding="utf-8"?>
+<file path=ppt/notesSlides/notesSlide19.xml><?xml version="1.0" encoding="utf-8"?>
 <p:notes xmlns:a="http://schemas.openxmlformats.org/drawingml/2006/main" xmlns:r="http://schemas.openxmlformats.org/officeDocument/2006/relationships" xmlns:p="http://schemas.openxmlformats.org/presentationml/2006/main">
   <p:cSld>
     <p:spTree>
@@ -1391,7 +1634,7 @@
           <a:p>
             <a:fld id="{F7021451-1387-4CA6-816F-3879F97B5CBC}" type="slidenum">
               <a:rPr lang="en-US"/>
-              <a:t>17</a:t>
+              <a:t>19</a:t>
             </a:fld>
             <a:endParaRPr lang="en-US"/>
           </a:p>
@@ -1476,6 +1719,90 @@
             <a:fld id="{F7021451-1387-4CA6-816F-3879F97B5CBC}" type="slidenum">
               <a:rPr lang="en-US"/>
               <a:t>2</a:t>
+            </a:fld>
+            <a:endParaRPr lang="en-US"/>
+          </a:p>
+        </p:txBody>
+      </p:sp>
+    </p:spTree>
+    <p:extLst>
+      <p:ext uri="{BB962C8B-B14F-4D97-AF65-F5344CB8AC3E}">
+        <p14:creationId xmlns:p14="http://schemas.microsoft.com/office/powerpoint/2010/main" val="1024086991"/>
+      </p:ext>
+    </p:extLst>
+  </p:cSld>
+  <p:clrMapOvr>
+    <a:masterClrMapping/>
+  </p:clrMapOvr>
+</p:notes>
+</file>
+
+<file path=ppt/notesSlides/notesSlide20.xml><?xml version="1.0" encoding="utf-8"?>
+<p:notes xmlns:a="http://schemas.openxmlformats.org/drawingml/2006/main" xmlns:r="http://schemas.openxmlformats.org/officeDocument/2006/relationships" xmlns:p="http://schemas.openxmlformats.org/presentationml/2006/main">
+  <p:cSld>
+    <p:spTree>
+      <p:nvGrpSpPr>
+        <p:cNvPr id="1" name=""/>
+        <p:cNvGrpSpPr/>
+        <p:nvPr/>
+      </p:nvGrpSpPr>
+      <p:grpSpPr>
+        <a:xfrm>
+          <a:off x="0" y="0"/>
+          <a:ext cx="0" cy="0"/>
+          <a:chOff x="0" y="0"/>
+          <a:chExt cx="0" cy="0"/>
+        </a:xfrm>
+      </p:grpSpPr>
+      <p:sp>
+        <p:nvSpPr>
+          <p:cNvPr id="2" name="Slide Image Placeholder 1"/>
+          <p:cNvSpPr>
+            <a:spLocks noGrp="1" noRot="1" noChangeAspect="1"/>
+          </p:cNvSpPr>
+          <p:nvPr>
+            <p:ph type="sldImg"/>
+          </p:nvPr>
+        </p:nvSpPr>
+        <p:spPr/>
+      </p:sp>
+      <p:sp>
+        <p:nvSpPr>
+          <p:cNvPr id="3" name="Notes Placeholder 2"/>
+          <p:cNvSpPr>
+            <a:spLocks noGrp="1"/>
+          </p:cNvSpPr>
+          <p:nvPr>
+            <p:ph type="body" idx="1"/>
+          </p:nvPr>
+        </p:nvSpPr>
+        <p:spPr/>
+        <p:txBody>
+          <a:bodyPr/>
+          <a:lstStyle/>
+          <a:p>
+            <a:endParaRPr lang="en-US" dirty="0"/>
+          </a:p>
+        </p:txBody>
+      </p:sp>
+      <p:sp>
+        <p:nvSpPr>
+          <p:cNvPr id="4" name="Slide Number Placeholder 3"/>
+          <p:cNvSpPr>
+            <a:spLocks noGrp="1"/>
+          </p:cNvSpPr>
+          <p:nvPr>
+            <p:ph type="sldNum" sz="quarter" idx="10"/>
+          </p:nvPr>
+        </p:nvSpPr>
+        <p:spPr/>
+        <p:txBody>
+          <a:bodyPr/>
+          <a:lstStyle/>
+          <a:p>
+            <a:fld id="{F7021451-1387-4CA6-816F-3879F97B5CBC}" type="slidenum">
+              <a:rPr lang="en-US"/>
+              <a:t>20</a:t>
             </a:fld>
             <a:endParaRPr lang="en-US"/>
           </a:p>
@@ -2615,7 +2942,110 @@
                 <a:ea typeface="Calibri" pitchFamily="34" charset="-122"/>
                 <a:cs typeface="Calibri" pitchFamily="34" charset="-120"/>
               </a:rPr>
-              <a:t>di ottimizzazione (MILP) risolto con Pyomo</a:t>
+              <a:t>di </a:t>
+            </a:r>
+            <a:r>
+              <a:rPr lang="en-US" sz="1600" dirty="0" err="1">
+                <a:solidFill>
+                  <a:srgbClr val="CADCE8"/>
+                </a:solidFill>
+                <a:latin typeface="Calibri" pitchFamily="34" charset="0"/>
+                <a:ea typeface="Calibri" pitchFamily="34" charset="-122"/>
+                <a:cs typeface="Calibri" pitchFamily="34" charset="-120"/>
+              </a:rPr>
+              <a:t>ottimizzazione</a:t>
+            </a:r>
+            <a:r>
+              <a:rPr lang="en-US" sz="1600" dirty="0">
+                <a:solidFill>
+                  <a:srgbClr val="CADCE8"/>
+                </a:solidFill>
+                <a:latin typeface="Calibri" pitchFamily="34" charset="0"/>
+                <a:ea typeface="Calibri" pitchFamily="34" charset="-122"/>
+                <a:cs typeface="Calibri" pitchFamily="34" charset="-120"/>
+              </a:rPr>
+              <a:t> (MILP) </a:t>
+            </a:r>
+            <a:r>
+              <a:rPr lang="en-US" sz="1600" dirty="0" err="1">
+                <a:solidFill>
+                  <a:srgbClr val="CADCE8"/>
+                </a:solidFill>
+                <a:latin typeface="Calibri" pitchFamily="34" charset="0"/>
+                <a:ea typeface="Calibri" pitchFamily="34" charset="-122"/>
+                <a:cs typeface="Calibri" pitchFamily="34" charset="-120"/>
+              </a:rPr>
+              <a:t>risolto</a:t>
+            </a:r>
+            <a:r>
+              <a:rPr lang="en-US" sz="1600" dirty="0">
+                <a:solidFill>
+                  <a:srgbClr val="CADCE8"/>
+                </a:solidFill>
+                <a:latin typeface="Calibri" pitchFamily="34" charset="0"/>
+                <a:ea typeface="Calibri" pitchFamily="34" charset="-122"/>
+                <a:cs typeface="Calibri" pitchFamily="34" charset="-120"/>
+              </a:rPr>
+              <a:t> con </a:t>
+            </a:r>
+            <a:r>
+              <a:rPr lang="en-US" sz="1600" dirty="0" err="1">
+                <a:solidFill>
+                  <a:srgbClr val="CADCE8"/>
+                </a:solidFill>
+                <a:latin typeface="Calibri" pitchFamily="34" charset="0"/>
+                <a:ea typeface="Calibri" pitchFamily="34" charset="-122"/>
+                <a:cs typeface="Calibri" pitchFamily="34" charset="-120"/>
+              </a:rPr>
+              <a:t>Pyomo</a:t>
+            </a:r>
+            <a:endParaRPr lang="en-US" sz="1600" dirty="0"/>
+          </a:p>
+        </p:txBody>
+      </p:sp>
+      <p:sp>
+        <p:nvSpPr>
+          <p:cNvPr id="4" name="Text 6">
+            <a:extLst>
+              <a:ext uri="{FF2B5EF4-FFF2-40B4-BE49-F238E27FC236}">
+                <a16:creationId xmlns:a16="http://schemas.microsoft.com/office/drawing/2014/main" id="{0783428A-3434-CE03-9015-45915F6A153B}"/>
+              </a:ext>
+            </a:extLst>
+          </p:cNvPr>
+          <p:cNvSpPr/>
+          <p:nvPr/>
+        </p:nvSpPr>
+        <p:spPr>
+          <a:xfrm>
+            <a:off x="548640" y="5204888"/>
+            <a:ext cx="9144000" cy="731520"/>
+          </a:xfrm>
+          <a:prstGeom prst="rect">
+            <a:avLst/>
+          </a:prstGeom>
+          <a:noFill/>
+          <a:ln/>
+        </p:spPr>
+        <p:txBody>
+          <a:bodyPr wrap="square" lIns="0" tIns="0" rIns="0" bIns="0" rtlCol="0" anchor="ctr"/>
+          <a:lstStyle/>
+          <a:p>
+            <a:pPr marL="0" indent="0">
+              <a:lnSpc>
+                <a:spcPct val="120000"/>
+              </a:lnSpc>
+              <a:buNone/>
+            </a:pPr>
+            <a:r>
+              <a:rPr lang="en-US" sz="1600" dirty="0">
+                <a:solidFill>
+                  <a:srgbClr val="CADCE8"/>
+                </a:solidFill>
+                <a:latin typeface="Calibri" pitchFamily="34" charset="0"/>
+                <a:ea typeface="Calibri" pitchFamily="34" charset="-122"/>
+                <a:cs typeface="Calibri" pitchFamily="34" charset="-120"/>
+              </a:rPr>
+              <a:t>--Claudia Lara Cordova </a:t>
             </a:r>
             <a:endParaRPr lang="en-US" sz="1600" dirty="0"/>
           </a:p>
@@ -3459,45 +3889,6 @@
           </a:p>
         </p:txBody>
       </p:sp>
-      <p:sp>
-        <p:nvSpPr>
-          <p:cNvPr id="25" name="Text 23"/>
-          <p:cNvSpPr/>
-          <p:nvPr/>
-        </p:nvSpPr>
-        <p:spPr>
-          <a:xfrm>
-            <a:off x="11094415" y="6473952"/>
-            <a:ext cx="548640" cy="274320"/>
-          </a:xfrm>
-          <a:prstGeom prst="rect">
-            <a:avLst/>
-          </a:prstGeom>
-          <a:noFill/>
-          <a:ln/>
-        </p:spPr>
-        <p:txBody>
-          <a:bodyPr wrap="square" lIns="0" tIns="0" rIns="0" bIns="0" rtlCol="0" anchor="ctr"/>
-          <a:lstStyle/>
-          <a:p>
-            <a:pPr marL="0" indent="0" algn="r">
-              <a:buNone/>
-            </a:pPr>
-            <a:r>
-              <a:rPr lang="en-US" sz="900" dirty="0">
-                <a:solidFill>
-                  <a:srgbClr val="6B7A85"/>
-                </a:solidFill>
-                <a:latin typeface="Calibri" pitchFamily="34" charset="0"/>
-                <a:ea typeface="Calibri" pitchFamily="34" charset="-122"/>
-                <a:cs typeface="Calibri" pitchFamily="34" charset="-120"/>
-              </a:rPr>
-              <a:t>10</a:t>
-            </a:r>
-            <a:endParaRPr lang="en-US" sz="900" dirty="0"/>
-          </a:p>
-        </p:txBody>
-      </p:sp>
     </p:spTree>
   </p:cSld>
   <p:clrMapOvr>
@@ -4812,7 +5203,7 @@
         </p:nvSpPr>
         <p:spPr>
           <a:xfrm>
-            <a:off x="548640" y="5623560"/>
+            <a:off x="472288" y="5285232"/>
             <a:ext cx="11094415" cy="457200"/>
           </a:xfrm>
           <a:prstGeom prst="rect">
@@ -4840,45 +5231,6 @@
               <a:t>Nel codice questo ciclo è la funzione run_mpc_simulation, che chiama solve_mpc_step ad ogni ora.</a:t>
             </a:r>
             <a:endParaRPr lang="en-US" sz="1250" dirty="0"/>
-          </a:p>
-        </p:txBody>
-      </p:sp>
-      <p:sp>
-        <p:nvSpPr>
-          <p:cNvPr id="27" name="Text 25"/>
-          <p:cNvSpPr/>
-          <p:nvPr/>
-        </p:nvSpPr>
-        <p:spPr>
-          <a:xfrm>
-            <a:off x="11094415" y="6473952"/>
-            <a:ext cx="548640" cy="274320"/>
-          </a:xfrm>
-          <a:prstGeom prst="rect">
-            <a:avLst/>
-          </a:prstGeom>
-          <a:noFill/>
-          <a:ln/>
-        </p:spPr>
-        <p:txBody>
-          <a:bodyPr wrap="square" lIns="0" tIns="0" rIns="0" bIns="0" rtlCol="0" anchor="ctr"/>
-          <a:lstStyle/>
-          <a:p>
-            <a:pPr marL="0" indent="0" algn="r">
-              <a:buNone/>
-            </a:pPr>
-            <a:r>
-              <a:rPr lang="en-US" sz="900" dirty="0">
-                <a:solidFill>
-                  <a:srgbClr val="6B7A85"/>
-                </a:solidFill>
-                <a:latin typeface="Calibri" pitchFamily="34" charset="0"/>
-                <a:ea typeface="Calibri" pitchFamily="34" charset="-122"/>
-                <a:cs typeface="Calibri" pitchFamily="34" charset="-120"/>
-              </a:rPr>
-              <a:t>12</a:t>
-            </a:r>
-            <a:endParaRPr lang="en-US" sz="900" dirty="0"/>
           </a:p>
         </p:txBody>
       </p:sp>
@@ -5684,45 +6036,6 @@
           </a:p>
         </p:txBody>
       </p:sp>
-      <p:sp>
-        <p:nvSpPr>
-          <p:cNvPr id="24" name="Text 22"/>
-          <p:cNvSpPr/>
-          <p:nvPr/>
-        </p:nvSpPr>
-        <p:spPr>
-          <a:xfrm>
-            <a:off x="11094415" y="6473952"/>
-            <a:ext cx="548640" cy="274320"/>
-          </a:xfrm>
-          <a:prstGeom prst="rect">
-            <a:avLst/>
-          </a:prstGeom>
-          <a:noFill/>
-          <a:ln/>
-        </p:spPr>
-        <p:txBody>
-          <a:bodyPr wrap="square" lIns="0" tIns="0" rIns="0" bIns="0" rtlCol="0" anchor="ctr"/>
-          <a:lstStyle/>
-          <a:p>
-            <a:pPr marL="0" indent="0" algn="r">
-              <a:buNone/>
-            </a:pPr>
-            <a:r>
-              <a:rPr lang="en-US" sz="900" dirty="0">
-                <a:solidFill>
-                  <a:srgbClr val="6B7A85"/>
-                </a:solidFill>
-                <a:latin typeface="Calibri" pitchFamily="34" charset="0"/>
-                <a:ea typeface="Calibri" pitchFamily="34" charset="-122"/>
-                <a:cs typeface="Calibri" pitchFamily="34" charset="-120"/>
-              </a:rPr>
-              <a:t>13</a:t>
-            </a:r>
-            <a:endParaRPr lang="en-US" sz="900" dirty="0"/>
-          </a:p>
-        </p:txBody>
-      </p:sp>
     </p:spTree>
   </p:cSld>
   <p:clrMapOvr>
@@ -6771,45 +7084,6 @@
           </a:p>
         </p:txBody>
       </p:sp>
-      <p:sp>
-        <p:nvSpPr>
-          <p:cNvPr id="32" name="Text 30"/>
-          <p:cNvSpPr/>
-          <p:nvPr/>
-        </p:nvSpPr>
-        <p:spPr>
-          <a:xfrm>
-            <a:off x="11094415" y="6473952"/>
-            <a:ext cx="548640" cy="274320"/>
-          </a:xfrm>
-          <a:prstGeom prst="rect">
-            <a:avLst/>
-          </a:prstGeom>
-          <a:noFill/>
-          <a:ln/>
-        </p:spPr>
-        <p:txBody>
-          <a:bodyPr wrap="square" lIns="0" tIns="0" rIns="0" bIns="0" rtlCol="0" anchor="ctr"/>
-          <a:lstStyle/>
-          <a:p>
-            <a:pPr marL="0" indent="0" algn="r">
-              <a:buNone/>
-            </a:pPr>
-            <a:r>
-              <a:rPr lang="en-US" sz="900" dirty="0">
-                <a:solidFill>
-                  <a:srgbClr val="6B7A85"/>
-                </a:solidFill>
-                <a:latin typeface="Calibri" pitchFamily="34" charset="0"/>
-                <a:ea typeface="Calibri" pitchFamily="34" charset="-122"/>
-                <a:cs typeface="Calibri" pitchFamily="34" charset="-120"/>
-              </a:rPr>
-              <a:t>14</a:t>
-            </a:r>
-            <a:endParaRPr lang="en-US" sz="900" dirty="0"/>
-          </a:p>
-        </p:txBody>
-      </p:sp>
     </p:spTree>
   </p:cSld>
   <p:clrMapOvr>
@@ -6819,6 +7093,1356 @@
 </file>
 
 <file path=ppt/slides/slide15.xml><?xml version="1.0" encoding="utf-8"?>
+<p:sld xmlns:a="http://schemas.openxmlformats.org/drawingml/2006/main" xmlns:r="http://schemas.openxmlformats.org/officeDocument/2006/relationships" xmlns:p="http://schemas.openxmlformats.org/presentationml/2006/main">
+  <p:cSld>
+    <p:bg>
+      <p:bgPr>
+        <a:solidFill>
+          <a:srgbClr val="FFFFFF"/>
+        </a:solidFill>
+        <a:effectLst/>
+      </p:bgPr>
+    </p:bg>
+    <p:spTree>
+      <p:nvGrpSpPr>
+        <p:cNvPr id="1" name="">
+          <a:extLst>
+            <a:ext uri="{FF2B5EF4-FFF2-40B4-BE49-F238E27FC236}">
+              <a16:creationId xmlns:a16="http://schemas.microsoft.com/office/drawing/2014/main" id="{22BE5A7C-2CD5-E406-0CEA-F62D6F8940E9}"/>
+            </a:ext>
+          </a:extLst>
+        </p:cNvPr>
+        <p:cNvGrpSpPr/>
+        <p:nvPr/>
+      </p:nvGrpSpPr>
+      <p:grpSpPr>
+        <a:xfrm>
+          <a:off x="0" y="0"/>
+          <a:ext cx="0" cy="0"/>
+          <a:chOff x="0" y="0"/>
+          <a:chExt cx="0" cy="0"/>
+        </a:xfrm>
+      </p:grpSpPr>
+      <p:sp>
+        <p:nvSpPr>
+          <p:cNvPr id="3" name="Text 1">
+            <a:extLst>
+              <a:ext uri="{FF2B5EF4-FFF2-40B4-BE49-F238E27FC236}">
+                <a16:creationId xmlns:a16="http://schemas.microsoft.com/office/drawing/2014/main" id="{1DBF3E3D-3553-55FF-F6E0-577EF8C0CB01}"/>
+              </a:ext>
+            </a:extLst>
+          </p:cNvPr>
+          <p:cNvSpPr/>
+          <p:nvPr/>
+        </p:nvSpPr>
+        <p:spPr>
+          <a:xfrm>
+            <a:off x="548640" y="713232"/>
+            <a:ext cx="11094415" cy="777240"/>
+          </a:xfrm>
+          <a:prstGeom prst="rect">
+            <a:avLst/>
+          </a:prstGeom>
+          <a:noFill/>
+          <a:ln/>
+        </p:spPr>
+        <p:txBody>
+          <a:bodyPr wrap="square" lIns="0" tIns="0" rIns="0" bIns="0" rtlCol="0" anchor="ctr"/>
+          <a:lstStyle/>
+          <a:p>
+            <a:r>
+              <a:rPr lang="it-IT" sz="3000" b="1" dirty="0">
+                <a:solidFill>
+                  <a:srgbClr val="0B3D59"/>
+                </a:solidFill>
+                <a:latin typeface="Cambria" pitchFamily="34" charset="0"/>
+              </a:rPr>
+              <a:t>Produzione rinnovabile e carico</a:t>
+            </a:r>
+          </a:p>
+          <a:p>
+            <a:pPr marL="0" indent="0">
+              <a:buNone/>
+            </a:pPr>
+            <a:endParaRPr lang="en-US" sz="3000" dirty="0"/>
+          </a:p>
+        </p:txBody>
+      </p:sp>
+      <p:pic>
+        <p:nvPicPr>
+          <p:cNvPr id="34" name="Immagine 33">
+            <a:extLst>
+              <a:ext uri="{FF2B5EF4-FFF2-40B4-BE49-F238E27FC236}">
+                <a16:creationId xmlns:a16="http://schemas.microsoft.com/office/drawing/2014/main" id="{2CD08551-3A64-B948-9987-7887FCC65596}"/>
+              </a:ext>
+            </a:extLst>
+          </p:cNvPr>
+          <p:cNvPicPr>
+            <a:picLocks noChangeAspect="1"/>
+          </p:cNvPicPr>
+          <p:nvPr/>
+        </p:nvPicPr>
+        <p:blipFill>
+          <a:blip r:embed="rId3"/>
+          <a:stretch>
+            <a:fillRect/>
+          </a:stretch>
+        </p:blipFill>
+        <p:spPr>
+          <a:xfrm>
+            <a:off x="0" y="1101852"/>
+            <a:ext cx="11461345" cy="4525191"/>
+          </a:xfrm>
+          <a:prstGeom prst="rect">
+            <a:avLst/>
+          </a:prstGeom>
+        </p:spPr>
+      </p:pic>
+      <p:graphicFrame>
+        <p:nvGraphicFramePr>
+          <p:cNvPr id="38" name="Tabella 37">
+            <a:extLst>
+              <a:ext uri="{FF2B5EF4-FFF2-40B4-BE49-F238E27FC236}">
+                <a16:creationId xmlns:a16="http://schemas.microsoft.com/office/drawing/2014/main" id="{F2954521-BB21-89D1-F83F-F11FEB003F8F}"/>
+              </a:ext>
+            </a:extLst>
+          </p:cNvPr>
+          <p:cNvGraphicFramePr>
+            <a:graphicFrameLocks noGrp="1"/>
+          </p:cNvGraphicFramePr>
+          <p:nvPr>
+            <p:extLst>
+              <p:ext uri="{D42A27DB-BD31-4B8C-83A1-F6EECF244321}">
+                <p14:modId xmlns:p14="http://schemas.microsoft.com/office/powerpoint/2010/main" val="3902470627"/>
+              </p:ext>
+            </p:extLst>
+          </p:nvPr>
+        </p:nvGraphicFramePr>
+        <p:xfrm>
+          <a:off x="599912" y="5521833"/>
+          <a:ext cx="5130760" cy="1158307"/>
+        </p:xfrm>
+        <a:graphic>
+          <a:graphicData uri="http://schemas.openxmlformats.org/drawingml/2006/table">
+            <a:tbl>
+              <a:tblPr>
+                <a:tableStyleId>{5C22544A-7EE6-4342-B048-85BDC9FD1C3A}</a:tableStyleId>
+              </a:tblPr>
+              <a:tblGrid>
+                <a:gridCol w="2565380">
+                  <a:extLst>
+                    <a:ext uri="{9D8B030D-6E8A-4147-A177-3AD203B41FA5}">
+                      <a16:colId xmlns:a16="http://schemas.microsoft.com/office/drawing/2014/main" val="89691916"/>
+                    </a:ext>
+                  </a:extLst>
+                </a:gridCol>
+                <a:gridCol w="2565380">
+                  <a:extLst>
+                    <a:ext uri="{9D8B030D-6E8A-4147-A177-3AD203B41FA5}">
+                      <a16:colId xmlns:a16="http://schemas.microsoft.com/office/drawing/2014/main" val="1428581068"/>
+                    </a:ext>
+                  </a:extLst>
+                </a:gridCol>
+              </a:tblGrid>
+              <a:tr h="377257">
+                <a:tc>
+                  <a:txBody>
+                    <a:bodyPr/>
+                    <a:lstStyle/>
+                    <a:p>
+                      <a:pPr marL="0" marR="0">
+                        <a:buNone/>
+                      </a:pPr>
+                      <a:r>
+                        <a:rPr lang="it-IT" sz="975">
+                          <a:effectLst/>
+                        </a:rPr>
+                        <a:t>Nera – Carico</a:t>
+                      </a:r>
+                      <a:endParaRPr lang="it-IT" sz="975">
+                        <a:effectLst/>
+                        <a:latin typeface="Helvetica Neue" panose="02000503000000020004" pitchFamily="2" charset="0"/>
+                      </a:endParaRPr>
+                    </a:p>
+                  </a:txBody>
+                  <a:tcPr marL="47625" marR="47625" marT="9525" marB="9525"/>
+                </a:tc>
+                <a:tc>
+                  <a:txBody>
+                    <a:bodyPr/>
+                    <a:lstStyle/>
+                    <a:p>
+                      <a:pPr marL="0" marR="0">
+                        <a:buNone/>
+                      </a:pPr>
+                      <a:r>
+                        <a:rPr lang="it-IT" sz="900" dirty="0" err="1">
+                          <a:effectLst/>
+                        </a:rPr>
+                        <a:t>P_ul</a:t>
+                      </a:r>
+                      <a:r>
+                        <a:rPr lang="it-IT" sz="975" dirty="0">
+                          <a:effectLst/>
+                        </a:rPr>
+                        <a:t>, la domanda dell'edificio, non controllabile: va sempre soddisfatta (obiettivo b).</a:t>
+                      </a:r>
+                      <a:endParaRPr lang="it-IT" sz="975" dirty="0">
+                        <a:effectLst/>
+                        <a:latin typeface="Helvetica Neue" panose="02000503000000020004" pitchFamily="2" charset="0"/>
+                      </a:endParaRPr>
+                    </a:p>
+                  </a:txBody>
+                  <a:tcPr marL="47625" marR="47625" marT="9525" marB="9525"/>
+                </a:tc>
+                <a:extLst>
+                  <a:ext uri="{0D108BD9-81ED-4DB2-BD59-A6C34878D82A}">
+                    <a16:rowId xmlns:a16="http://schemas.microsoft.com/office/drawing/2014/main" val="1911797583"/>
+                  </a:ext>
+                </a:extLst>
+              </a:tr>
+              <a:tr h="199992">
+                <a:tc>
+                  <a:txBody>
+                    <a:bodyPr/>
+                    <a:lstStyle/>
+                    <a:p>
+                      <a:pPr marL="0" marR="0">
+                        <a:buNone/>
+                      </a:pPr>
+                      <a:r>
+                        <a:rPr lang="it-IT" sz="975">
+                          <a:effectLst/>
+                        </a:rPr>
+                        <a:t>Verde – Rinnovabili</a:t>
+                      </a:r>
+                      <a:endParaRPr lang="it-IT" sz="975">
+                        <a:effectLst/>
+                        <a:latin typeface="Helvetica Neue" panose="02000503000000020004" pitchFamily="2" charset="0"/>
+                      </a:endParaRPr>
+                    </a:p>
+                  </a:txBody>
+                  <a:tcPr marL="47625" marR="47625" marT="9525" marB="9525"/>
+                </a:tc>
+                <a:tc>
+                  <a:txBody>
+                    <a:bodyPr/>
+                    <a:lstStyle/>
+                    <a:p>
+                      <a:pPr marL="0" marR="0">
+                        <a:buNone/>
+                      </a:pPr>
+                      <a:r>
+                        <a:rPr lang="it-IT" sz="900" dirty="0" err="1">
+                          <a:effectLst/>
+                        </a:rPr>
+                        <a:t>P_pv</a:t>
+                      </a:r>
+                      <a:r>
+                        <a:rPr lang="it-IT" sz="900" dirty="0">
+                          <a:effectLst/>
+                        </a:rPr>
+                        <a:t> + </a:t>
+                      </a:r>
+                      <a:r>
+                        <a:rPr lang="it-IT" sz="900" dirty="0" err="1">
+                          <a:effectLst/>
+                        </a:rPr>
+                        <a:t>P_w</a:t>
+                      </a:r>
+                      <a:r>
+                        <a:rPr lang="it-IT" sz="975" dirty="0">
+                          <a:effectLst/>
+                        </a:rPr>
+                        <a:t> effettivamente usata (PV 4 MW + eolico 8 MW). Molto variabile, spesso sotto il carico.</a:t>
+                      </a:r>
+                      <a:endParaRPr lang="it-IT" sz="975" dirty="0">
+                        <a:effectLst/>
+                        <a:latin typeface="Helvetica Neue" panose="02000503000000020004" pitchFamily="2" charset="0"/>
+                      </a:endParaRPr>
+                    </a:p>
+                  </a:txBody>
+                  <a:tcPr marL="47625" marR="47625" marT="9525" marB="9525"/>
+                </a:tc>
+                <a:extLst>
+                  <a:ext uri="{0D108BD9-81ED-4DB2-BD59-A6C34878D82A}">
+                    <a16:rowId xmlns:a16="http://schemas.microsoft.com/office/drawing/2014/main" val="217594940"/>
+                  </a:ext>
+                </a:extLst>
+              </a:tr>
+              <a:tr h="199992">
+                <a:tc>
+                  <a:txBody>
+                    <a:bodyPr/>
+                    <a:lstStyle/>
+                    <a:p>
+                      <a:pPr marL="0" marR="0">
+                        <a:buNone/>
+                      </a:pPr>
+                      <a:r>
+                        <a:rPr lang="it-IT" sz="975">
+                          <a:effectLst/>
+                        </a:rPr>
+                        <a:t>Arancione – Curtailment</a:t>
+                      </a:r>
+                      <a:endParaRPr lang="it-IT" sz="975">
+                        <a:effectLst/>
+                        <a:latin typeface="Helvetica Neue" panose="02000503000000020004" pitchFamily="2" charset="0"/>
+                      </a:endParaRPr>
+                    </a:p>
+                  </a:txBody>
+                  <a:tcPr marL="47625" marR="47625" marT="9525" marB="9525"/>
+                </a:tc>
+                <a:tc>
+                  <a:txBody>
+                    <a:bodyPr/>
+                    <a:lstStyle/>
+                    <a:p>
+                      <a:pPr marL="0" marR="0">
+                        <a:buNone/>
+                      </a:pPr>
+                      <a:r>
+                        <a:rPr lang="it-IT" sz="975" dirty="0">
+                          <a:effectLst/>
+                        </a:rPr>
+                        <a:t>Energia rinnovabile sprecata </a:t>
+                      </a:r>
+                      <a:r>
+                        <a:rPr lang="it-IT" sz="900" dirty="0" err="1">
+                          <a:effectLst/>
+                        </a:rPr>
+                        <a:t>P_c</a:t>
+                      </a:r>
+                      <a:r>
+                        <a:rPr lang="it-IT" sz="975" dirty="0">
+                          <a:effectLst/>
+                        </a:rPr>
+                        <a:t>. Resta a zero: il sistema non butta mai via rinnovabile.</a:t>
+                      </a:r>
+                      <a:endParaRPr lang="it-IT" sz="975" dirty="0">
+                        <a:effectLst/>
+                        <a:latin typeface="Helvetica Neue" panose="02000503000000020004" pitchFamily="2" charset="0"/>
+                      </a:endParaRPr>
+                    </a:p>
+                  </a:txBody>
+                  <a:tcPr marL="47625" marR="47625" marT="9525" marB="9525"/>
+                </a:tc>
+                <a:extLst>
+                  <a:ext uri="{0D108BD9-81ED-4DB2-BD59-A6C34878D82A}">
+                    <a16:rowId xmlns:a16="http://schemas.microsoft.com/office/drawing/2014/main" val="3369089069"/>
+                  </a:ext>
+                </a:extLst>
+              </a:tr>
+            </a:tbl>
+          </a:graphicData>
+        </a:graphic>
+      </p:graphicFrame>
+    </p:spTree>
+    <p:extLst>
+      <p:ext uri="{BB962C8B-B14F-4D97-AF65-F5344CB8AC3E}">
+        <p14:creationId xmlns:p14="http://schemas.microsoft.com/office/powerpoint/2010/main" val="2355657759"/>
+      </p:ext>
+    </p:extLst>
+  </p:cSld>
+  <p:clrMapOvr>
+    <a:masterClrMapping/>
+  </p:clrMapOvr>
+</p:sld>
+</file>
+
+<file path=ppt/slides/slide16.xml><?xml version="1.0" encoding="utf-8"?>
+<p:sld xmlns:a="http://schemas.openxmlformats.org/drawingml/2006/main" xmlns:r="http://schemas.openxmlformats.org/officeDocument/2006/relationships" xmlns:p="http://schemas.openxmlformats.org/presentationml/2006/main">
+  <p:cSld>
+    <p:bg>
+      <p:bgPr>
+        <a:solidFill>
+          <a:schemeClr val="bg1"/>
+        </a:solidFill>
+        <a:effectLst/>
+      </p:bgPr>
+    </p:bg>
+    <p:spTree>
+      <p:nvGrpSpPr>
+        <p:cNvPr id="1" name="">
+          <a:extLst>
+            <a:ext uri="{FF2B5EF4-FFF2-40B4-BE49-F238E27FC236}">
+              <a16:creationId xmlns:a16="http://schemas.microsoft.com/office/drawing/2014/main" id="{DB936D8E-5284-8BCF-08BC-7EDEC8898C1B}"/>
+            </a:ext>
+          </a:extLst>
+        </p:cNvPr>
+        <p:cNvGrpSpPr/>
+        <p:nvPr/>
+      </p:nvGrpSpPr>
+      <p:grpSpPr>
+        <a:xfrm>
+          <a:off x="0" y="0"/>
+          <a:ext cx="0" cy="0"/>
+          <a:chOff x="0" y="0"/>
+          <a:chExt cx="0" cy="0"/>
+        </a:xfrm>
+      </p:grpSpPr>
+      <p:sp useBgFill="1">
+        <p:nvSpPr>
+          <p:cNvPr id="12" name="Rectangle 11">
+            <a:extLst>
+              <a:ext uri="{FF2B5EF4-FFF2-40B4-BE49-F238E27FC236}">
+                <a16:creationId xmlns:a16="http://schemas.microsoft.com/office/drawing/2014/main" id="{8761DDFE-071F-4200-B0AA-394476C2D2D6}"/>
+              </a:ext>
+              <a:ext uri="{C183D7F6-B498-43B3-948B-1728B52AA6E4}">
+                <adec:decorative xmlns:adec="http://schemas.microsoft.com/office/drawing/2017/decorative" val="1"/>
+              </a:ext>
+            </a:extLst>
+          </p:cNvPr>
+          <p:cNvSpPr>
+            <a:spLocks noGrp="1" noRot="1" noChangeAspect="1" noMove="1" noResize="1" noEditPoints="1" noAdjustHandles="1" noChangeArrowheads="1" noChangeShapeType="1" noTextEdit="1"/>
+          </p:cNvSpPr>
+          <p:nvPr>
+            <p:extLst>
+              <p:ext uri="{386F3935-93C4-4BCD-93E2-E3B085C9AB24}">
+                <p16:designElem xmlns:p16="http://schemas.microsoft.com/office/powerpoint/2015/main" val="1"/>
+              </p:ext>
+            </p:extLst>
+          </p:nvPr>
+        </p:nvSpPr>
+        <p:spPr>
+          <a:xfrm>
+            <a:off x="-1" y="0"/>
+            <a:ext cx="12188952" cy="6858000"/>
+          </a:xfrm>
+          <a:prstGeom prst="rect">
+            <a:avLst/>
+          </a:prstGeom>
+          <a:ln>
+            <a:noFill/>
+          </a:ln>
+        </p:spPr>
+        <p:style>
+          <a:lnRef idx="2">
+            <a:schemeClr val="accent1">
+              <a:shade val="50000"/>
+            </a:schemeClr>
+          </a:lnRef>
+          <a:fillRef idx="1">
+            <a:schemeClr val="accent1"/>
+          </a:fillRef>
+          <a:effectRef idx="0">
+            <a:schemeClr val="accent1"/>
+          </a:effectRef>
+          <a:fontRef idx="minor">
+            <a:schemeClr val="lt1"/>
+          </a:fontRef>
+        </p:style>
+        <p:txBody>
+          <a:bodyPr rtlCol="0" anchor="ctr"/>
+          <a:lstStyle/>
+          <a:p>
+            <a:pPr algn="ctr"/>
+            <a:endParaRPr lang="en-US"/>
+          </a:p>
+        </p:txBody>
+      </p:sp>
+      <p:sp>
+        <p:nvSpPr>
+          <p:cNvPr id="7" name="CasellaDiTesto 6">
+            <a:extLst>
+              <a:ext uri="{FF2B5EF4-FFF2-40B4-BE49-F238E27FC236}">
+                <a16:creationId xmlns:a16="http://schemas.microsoft.com/office/drawing/2014/main" id="{10DC74F9-DA00-539A-83DC-F6E637C964F3}"/>
+              </a:ext>
+            </a:extLst>
+          </p:cNvPr>
+          <p:cNvSpPr txBox="1"/>
+          <p:nvPr/>
+        </p:nvSpPr>
+        <p:spPr>
+          <a:xfrm>
+            <a:off x="6186619" y="547815"/>
+            <a:ext cx="5178960" cy="1680519"/>
+          </a:xfrm>
+          <a:prstGeom prst="rect">
+            <a:avLst/>
+          </a:prstGeom>
+        </p:spPr>
+        <p:txBody>
+          <a:bodyPr vert="horz" lIns="91440" tIns="45720" rIns="91440" bIns="45720" rtlCol="0" anchor="ctr">
+            <a:normAutofit/>
+          </a:bodyPr>
+          <a:lstStyle/>
+          <a:p>
+            <a:pPr marR="0">
+              <a:lnSpc>
+                <a:spcPct val="90000"/>
+              </a:lnSpc>
+              <a:spcAft>
+                <a:spcPts val="600"/>
+              </a:spcAft>
+            </a:pPr>
+            <a:endParaRPr lang="en-US" sz="1100" dirty="0">
+              <a:effectLst/>
+            </a:endParaRPr>
+          </a:p>
+        </p:txBody>
+      </p:sp>
+      <p:pic>
+        <p:nvPicPr>
+          <p:cNvPr id="4" name="Immagine 3">
+            <a:extLst>
+              <a:ext uri="{FF2B5EF4-FFF2-40B4-BE49-F238E27FC236}">
+                <a16:creationId xmlns:a16="http://schemas.microsoft.com/office/drawing/2014/main" id="{C972465A-90A0-01F6-5FC7-5C912410B80D}"/>
+              </a:ext>
+            </a:extLst>
+          </p:cNvPr>
+          <p:cNvPicPr>
+            <a:picLocks noChangeAspect="1"/>
+          </p:cNvPicPr>
+          <p:nvPr/>
+        </p:nvPicPr>
+        <p:blipFill>
+          <a:blip r:embed="rId3"/>
+          <a:stretch>
+            <a:fillRect/>
+          </a:stretch>
+        </p:blipFill>
+        <p:spPr>
+          <a:xfrm>
+            <a:off x="838198" y="1420586"/>
+            <a:ext cx="9816281" cy="3877429"/>
+          </a:xfrm>
+          <a:prstGeom prst="rect">
+            <a:avLst/>
+          </a:prstGeom>
+        </p:spPr>
+      </p:pic>
+      <p:graphicFrame>
+        <p:nvGraphicFramePr>
+          <p:cNvPr id="5" name="Tabella 4">
+            <a:extLst>
+              <a:ext uri="{FF2B5EF4-FFF2-40B4-BE49-F238E27FC236}">
+                <a16:creationId xmlns:a16="http://schemas.microsoft.com/office/drawing/2014/main" id="{0EEEDF22-33D0-FDBC-F18B-5E621DBC35EE}"/>
+              </a:ext>
+            </a:extLst>
+          </p:cNvPr>
+          <p:cNvGraphicFramePr>
+            <a:graphicFrameLocks noGrp="1"/>
+          </p:cNvGraphicFramePr>
+          <p:nvPr>
+            <p:extLst>
+              <p:ext uri="{D42A27DB-BD31-4B8C-83A1-F6EECF244321}">
+                <p14:modId xmlns:p14="http://schemas.microsoft.com/office/powerpoint/2010/main" val="1476166893"/>
+              </p:ext>
+            </p:extLst>
+          </p:nvPr>
+        </p:nvGraphicFramePr>
+        <p:xfrm>
+          <a:off x="6590280" y="4902633"/>
+          <a:ext cx="5167187" cy="1878002"/>
+        </p:xfrm>
+        <a:graphic>
+          <a:graphicData uri="http://schemas.openxmlformats.org/drawingml/2006/table">
+            <a:tbl>
+              <a:tblPr firstRow="1" bandRow="1">
+                <a:tableStyleId>{5C22544A-7EE6-4342-B048-85BDC9FD1C3A}</a:tableStyleId>
+              </a:tblPr>
+              <a:tblGrid>
+                <a:gridCol w="1147391">
+                  <a:extLst>
+                    <a:ext uri="{9D8B030D-6E8A-4147-A177-3AD203B41FA5}">
+                      <a16:colId xmlns:a16="http://schemas.microsoft.com/office/drawing/2014/main" val="3968080165"/>
+                    </a:ext>
+                  </a:extLst>
+                </a:gridCol>
+                <a:gridCol w="1806411">
+                  <a:extLst>
+                    <a:ext uri="{9D8B030D-6E8A-4147-A177-3AD203B41FA5}">
+                      <a16:colId xmlns:a16="http://schemas.microsoft.com/office/drawing/2014/main" val="1014864147"/>
+                    </a:ext>
+                  </a:extLst>
+                </a:gridCol>
+                <a:gridCol w="2213385">
+                  <a:extLst>
+                    <a:ext uri="{9D8B030D-6E8A-4147-A177-3AD203B41FA5}">
+                      <a16:colId xmlns:a16="http://schemas.microsoft.com/office/drawing/2014/main" val="2412458428"/>
+                    </a:ext>
+                  </a:extLst>
+                </a:gridCol>
+              </a:tblGrid>
+              <a:tr h="303011">
+                <a:tc>
+                  <a:txBody>
+                    <a:bodyPr/>
+                    <a:lstStyle/>
+                    <a:p>
+                      <a:pPr marL="0" marR="0" algn="ctr">
+                        <a:buNone/>
+                      </a:pPr>
+                      <a:r>
+                        <a:rPr lang="it-IT" sz="1500">
+                          <a:effectLst/>
+                        </a:rPr>
+                        <a:t>Linea</a:t>
+                      </a:r>
+                      <a:endParaRPr lang="it-IT" sz="1500">
+                        <a:effectLst/>
+                        <a:latin typeface="Helvetica Neue" panose="02000503000000020004" pitchFamily="2" charset="0"/>
+                      </a:endParaRPr>
+                    </a:p>
+                  </a:txBody>
+                  <a:tcPr marL="69371" marR="69371" marT="13874" marB="13874"/>
+                </a:tc>
+                <a:tc>
+                  <a:txBody>
+                    <a:bodyPr/>
+                    <a:lstStyle/>
+                    <a:p>
+                      <a:pPr marL="0" marR="0" algn="ctr">
+                        <a:buNone/>
+                      </a:pPr>
+                      <a:r>
+                        <a:rPr lang="it-IT" sz="1500">
+                          <a:effectLst/>
+                        </a:rPr>
+                        <a:t>Sopra lo zero (+)</a:t>
+                      </a:r>
+                      <a:endParaRPr lang="it-IT" sz="1500">
+                        <a:effectLst/>
+                        <a:latin typeface="Helvetica Neue" panose="02000503000000020004" pitchFamily="2" charset="0"/>
+                      </a:endParaRPr>
+                    </a:p>
+                  </a:txBody>
+                  <a:tcPr marL="69371" marR="69371" marT="13874" marB="13874"/>
+                </a:tc>
+                <a:tc>
+                  <a:txBody>
+                    <a:bodyPr/>
+                    <a:lstStyle/>
+                    <a:p>
+                      <a:pPr marL="0" marR="0" algn="ctr">
+                        <a:buNone/>
+                      </a:pPr>
+                      <a:r>
+                        <a:rPr lang="it-IT" sz="1500">
+                          <a:effectLst/>
+                        </a:rPr>
+                        <a:t>Sotto lo zero (−)</a:t>
+                      </a:r>
+                      <a:endParaRPr lang="it-IT" sz="1500">
+                        <a:effectLst/>
+                        <a:latin typeface="Helvetica Neue" panose="02000503000000020004" pitchFamily="2" charset="0"/>
+                      </a:endParaRPr>
+                    </a:p>
+                  </a:txBody>
+                  <a:tcPr marL="69371" marR="69371" marT="13874" marB="13874"/>
+                </a:tc>
+                <a:extLst>
+                  <a:ext uri="{0D108BD9-81ED-4DB2-BD59-A6C34878D82A}">
+                    <a16:rowId xmlns:a16="http://schemas.microsoft.com/office/drawing/2014/main" val="1525570769"/>
+                  </a:ext>
+                </a:extLst>
+              </a:tr>
+              <a:tr h="524997">
+                <a:tc>
+                  <a:txBody>
+                    <a:bodyPr/>
+                    <a:lstStyle/>
+                    <a:p>
+                      <a:pPr marL="0" marR="0">
+                        <a:buNone/>
+                      </a:pPr>
+                      <a:r>
+                        <a:rPr lang="it-IT" sz="1500">
+                          <a:effectLst/>
+                        </a:rPr>
+                        <a:t>Blu – Rete</a:t>
+                      </a:r>
+                      <a:endParaRPr lang="it-IT" sz="1500">
+                        <a:effectLst/>
+                        <a:latin typeface="Helvetica Neue" panose="02000503000000020004" pitchFamily="2" charset="0"/>
+                      </a:endParaRPr>
+                    </a:p>
+                  </a:txBody>
+                  <a:tcPr marL="69371" marR="69371" marT="13874" marB="13874"/>
+                </a:tc>
+                <a:tc>
+                  <a:txBody>
+                    <a:bodyPr/>
+                    <a:lstStyle/>
+                    <a:p>
+                      <a:pPr marL="0" marR="0">
+                        <a:buNone/>
+                      </a:pPr>
+                      <a:r>
+                        <a:rPr lang="it-IT" sz="1500">
+                          <a:effectLst/>
+                        </a:rPr>
+                        <a:t>importazione (max 12 MW)</a:t>
+                      </a:r>
+                      <a:endParaRPr lang="it-IT" sz="1500">
+                        <a:effectLst/>
+                        <a:latin typeface="Helvetica Neue" panose="02000503000000020004" pitchFamily="2" charset="0"/>
+                      </a:endParaRPr>
+                    </a:p>
+                  </a:txBody>
+                  <a:tcPr marL="69371" marR="69371" marT="13874" marB="13874"/>
+                </a:tc>
+                <a:tc>
+                  <a:txBody>
+                    <a:bodyPr/>
+                    <a:lstStyle/>
+                    <a:p>
+                      <a:pPr marL="0" marR="0">
+                        <a:buNone/>
+                      </a:pPr>
+                      <a:r>
+                        <a:rPr lang="it-IT" sz="1500">
+                          <a:effectLst/>
+                        </a:rPr>
+                        <a:t>esportazione (max 10 MW)</a:t>
+                      </a:r>
+                      <a:endParaRPr lang="it-IT" sz="1500">
+                        <a:effectLst/>
+                        <a:latin typeface="Helvetica Neue" panose="02000503000000020004" pitchFamily="2" charset="0"/>
+                      </a:endParaRPr>
+                    </a:p>
+                  </a:txBody>
+                  <a:tcPr marL="69371" marR="69371" marT="13874" marB="13874"/>
+                </a:tc>
+                <a:extLst>
+                  <a:ext uri="{0D108BD9-81ED-4DB2-BD59-A6C34878D82A}">
+                    <a16:rowId xmlns:a16="http://schemas.microsoft.com/office/drawing/2014/main" val="2790393642"/>
+                  </a:ext>
+                </a:extLst>
+              </a:tr>
+              <a:tr h="524997">
+                <a:tc>
+                  <a:txBody>
+                    <a:bodyPr/>
+                    <a:lstStyle/>
+                    <a:p>
+                      <a:pPr marL="0" marR="0">
+                        <a:buNone/>
+                      </a:pPr>
+                      <a:r>
+                        <a:rPr lang="it-IT" sz="1500">
+                          <a:effectLst/>
+                        </a:rPr>
+                        <a:t>Verde – Batteria</a:t>
+                      </a:r>
+                      <a:endParaRPr lang="it-IT" sz="1500">
+                        <a:effectLst/>
+                        <a:latin typeface="Helvetica Neue" panose="02000503000000020004" pitchFamily="2" charset="0"/>
+                      </a:endParaRPr>
+                    </a:p>
+                  </a:txBody>
+                  <a:tcPr marL="69371" marR="69371" marT="13874" marB="13874"/>
+                </a:tc>
+                <a:tc>
+                  <a:txBody>
+                    <a:bodyPr/>
+                    <a:lstStyle/>
+                    <a:p>
+                      <a:pPr marL="0" marR="0">
+                        <a:buNone/>
+                      </a:pPr>
+                      <a:r>
+                        <a:rPr lang="it-IT" sz="1500">
+                          <a:effectLst/>
+                        </a:rPr>
+                        <a:t>scarica</a:t>
+                      </a:r>
+                      <a:endParaRPr lang="it-IT" sz="1500">
+                        <a:effectLst/>
+                        <a:latin typeface="Helvetica Neue" panose="02000503000000020004" pitchFamily="2" charset="0"/>
+                      </a:endParaRPr>
+                    </a:p>
+                  </a:txBody>
+                  <a:tcPr marL="69371" marR="69371" marT="13874" marB="13874"/>
+                </a:tc>
+                <a:tc>
+                  <a:txBody>
+                    <a:bodyPr/>
+                    <a:lstStyle/>
+                    <a:p>
+                      <a:pPr marL="0" marR="0">
+                        <a:buNone/>
+                      </a:pPr>
+                      <a:r>
+                        <a:rPr lang="it-IT" sz="1500">
+                          <a:effectLst/>
+                        </a:rPr>
+                        <a:t>carica</a:t>
+                      </a:r>
+                      <a:endParaRPr lang="it-IT" sz="1500">
+                        <a:effectLst/>
+                        <a:latin typeface="Helvetica Neue" panose="02000503000000020004" pitchFamily="2" charset="0"/>
+                      </a:endParaRPr>
+                    </a:p>
+                  </a:txBody>
+                  <a:tcPr marL="69371" marR="69371" marT="13874" marB="13874"/>
+                </a:tc>
+                <a:extLst>
+                  <a:ext uri="{0D108BD9-81ED-4DB2-BD59-A6C34878D82A}">
+                    <a16:rowId xmlns:a16="http://schemas.microsoft.com/office/drawing/2014/main" val="4290456352"/>
+                  </a:ext>
+                </a:extLst>
+              </a:tr>
+              <a:tr h="524997">
+                <a:tc>
+                  <a:txBody>
+                    <a:bodyPr/>
+                    <a:lstStyle/>
+                    <a:p>
+                      <a:pPr marL="0" marR="0">
+                        <a:buNone/>
+                      </a:pPr>
+                      <a:r>
+                        <a:rPr lang="it-IT" sz="1500">
+                          <a:effectLst/>
+                        </a:rPr>
+                        <a:t>Rossa – Idrogeno</a:t>
+                      </a:r>
+                      <a:endParaRPr lang="it-IT" sz="1500">
+                        <a:effectLst/>
+                        <a:latin typeface="Helvetica Neue" panose="02000503000000020004" pitchFamily="2" charset="0"/>
+                      </a:endParaRPr>
+                    </a:p>
+                  </a:txBody>
+                  <a:tcPr marL="69371" marR="69371" marT="13874" marB="13874"/>
+                </a:tc>
+                <a:tc>
+                  <a:txBody>
+                    <a:bodyPr/>
+                    <a:lstStyle/>
+                    <a:p>
+                      <a:pPr marL="0" marR="0">
+                        <a:buNone/>
+                      </a:pPr>
+                      <a:r>
+                        <a:rPr lang="it-IT" sz="1500">
+                          <a:effectLst/>
+                        </a:rPr>
+                        <a:t>fuel cell (H₂ → energia)</a:t>
+                      </a:r>
+                      <a:endParaRPr lang="it-IT" sz="1500">
+                        <a:effectLst/>
+                        <a:latin typeface="Helvetica Neue" panose="02000503000000020004" pitchFamily="2" charset="0"/>
+                      </a:endParaRPr>
+                    </a:p>
+                  </a:txBody>
+                  <a:tcPr marL="69371" marR="69371" marT="13874" marB="13874"/>
+                </a:tc>
+                <a:tc>
+                  <a:txBody>
+                    <a:bodyPr/>
+                    <a:lstStyle/>
+                    <a:p>
+                      <a:pPr marL="0" marR="0">
+                        <a:buNone/>
+                      </a:pPr>
+                      <a:r>
+                        <a:rPr lang="it-IT" sz="1500" dirty="0">
+                          <a:effectLst/>
+                        </a:rPr>
+                        <a:t>elettrolizzatore (energia → H₂)</a:t>
+                      </a:r>
+                      <a:endParaRPr lang="it-IT" sz="1500" dirty="0">
+                        <a:effectLst/>
+                        <a:latin typeface="Helvetica Neue" panose="02000503000000020004" pitchFamily="2" charset="0"/>
+                      </a:endParaRPr>
+                    </a:p>
+                  </a:txBody>
+                  <a:tcPr marL="69371" marR="69371" marT="13874" marB="13874"/>
+                </a:tc>
+                <a:extLst>
+                  <a:ext uri="{0D108BD9-81ED-4DB2-BD59-A6C34878D82A}">
+                    <a16:rowId xmlns:a16="http://schemas.microsoft.com/office/drawing/2014/main" val="2814135183"/>
+                  </a:ext>
+                </a:extLst>
+              </a:tr>
+            </a:tbl>
+          </a:graphicData>
+        </a:graphic>
+      </p:graphicFrame>
+      <p:sp>
+        <p:nvSpPr>
+          <p:cNvPr id="8" name="Text 1">
+            <a:extLst>
+              <a:ext uri="{FF2B5EF4-FFF2-40B4-BE49-F238E27FC236}">
+                <a16:creationId xmlns:a16="http://schemas.microsoft.com/office/drawing/2014/main" id="{45B559B5-235F-0F6D-6869-FFF4667BA05F}"/>
+              </a:ext>
+            </a:extLst>
+          </p:cNvPr>
+          <p:cNvSpPr/>
+          <p:nvPr/>
+        </p:nvSpPr>
+        <p:spPr>
+          <a:xfrm>
+            <a:off x="548640" y="713232"/>
+            <a:ext cx="11094415" cy="777240"/>
+          </a:xfrm>
+          <a:prstGeom prst="rect">
+            <a:avLst/>
+          </a:prstGeom>
+          <a:noFill/>
+          <a:ln/>
+        </p:spPr>
+        <p:txBody>
+          <a:bodyPr wrap="square" lIns="0" tIns="0" rIns="0" bIns="0" rtlCol="0" anchor="ctr"/>
+          <a:lstStyle/>
+          <a:p>
+            <a:r>
+              <a:rPr lang="it-IT" sz="3000" b="1" dirty="0">
+                <a:solidFill>
+                  <a:srgbClr val="0B3D59"/>
+                </a:solidFill>
+                <a:latin typeface="Cambria" pitchFamily="34" charset="0"/>
+              </a:rPr>
+              <a:t>Scambi controllati</a:t>
+            </a:r>
+            <a:endParaRPr lang="en-US" sz="3000" dirty="0"/>
+          </a:p>
+        </p:txBody>
+      </p:sp>
+    </p:spTree>
+    <p:extLst>
+      <p:ext uri="{BB962C8B-B14F-4D97-AF65-F5344CB8AC3E}">
+        <p14:creationId xmlns:p14="http://schemas.microsoft.com/office/powerpoint/2010/main" val="1338140777"/>
+      </p:ext>
+    </p:extLst>
+  </p:cSld>
+  <p:clrMapOvr>
+    <a:masterClrMapping/>
+  </p:clrMapOvr>
+</p:sld>
+</file>
+
+<file path=ppt/slides/slide17.xml><?xml version="1.0" encoding="utf-8"?>
+<p:sld xmlns:a="http://schemas.openxmlformats.org/drawingml/2006/main" xmlns:r="http://schemas.openxmlformats.org/officeDocument/2006/relationships" xmlns:p="http://schemas.openxmlformats.org/presentationml/2006/main">
+  <p:cSld>
+    <p:bg>
+      <p:bgPr>
+        <a:solidFill>
+          <a:schemeClr val="bg1"/>
+        </a:solidFill>
+        <a:effectLst/>
+      </p:bgPr>
+    </p:bg>
+    <p:spTree>
+      <p:nvGrpSpPr>
+        <p:cNvPr id="1" name="">
+          <a:extLst>
+            <a:ext uri="{FF2B5EF4-FFF2-40B4-BE49-F238E27FC236}">
+              <a16:creationId xmlns:a16="http://schemas.microsoft.com/office/drawing/2014/main" id="{4472C9C3-B768-E584-0C9A-CBD053CE82AC}"/>
+            </a:ext>
+          </a:extLst>
+        </p:cNvPr>
+        <p:cNvGrpSpPr/>
+        <p:nvPr/>
+      </p:nvGrpSpPr>
+      <p:grpSpPr>
+        <a:xfrm>
+          <a:off x="0" y="0"/>
+          <a:ext cx="0" cy="0"/>
+          <a:chOff x="0" y="0"/>
+          <a:chExt cx="0" cy="0"/>
+        </a:xfrm>
+      </p:grpSpPr>
+      <p:sp useBgFill="1">
+        <p:nvSpPr>
+          <p:cNvPr id="18" name="Rectangle 17">
+            <a:extLst>
+              <a:ext uri="{FF2B5EF4-FFF2-40B4-BE49-F238E27FC236}">
+                <a16:creationId xmlns:a16="http://schemas.microsoft.com/office/drawing/2014/main" id="{8761DDFE-071F-4200-B0AA-394476C2D2D6}"/>
+              </a:ext>
+              <a:ext uri="{C183D7F6-B498-43B3-948B-1728B52AA6E4}">
+                <adec:decorative xmlns:adec="http://schemas.microsoft.com/office/drawing/2017/decorative" val="1"/>
+              </a:ext>
+            </a:extLst>
+          </p:cNvPr>
+          <p:cNvSpPr>
+            <a:spLocks noGrp="1" noRot="1" noChangeAspect="1" noMove="1" noResize="1" noEditPoints="1" noAdjustHandles="1" noChangeArrowheads="1" noChangeShapeType="1" noTextEdit="1"/>
+          </p:cNvSpPr>
+          <p:nvPr>
+            <p:extLst>
+              <p:ext uri="{386F3935-93C4-4BCD-93E2-E3B085C9AB24}">
+                <p16:designElem xmlns:p16="http://schemas.microsoft.com/office/powerpoint/2015/main" val="1"/>
+              </p:ext>
+            </p:extLst>
+          </p:nvPr>
+        </p:nvSpPr>
+        <p:spPr>
+          <a:xfrm>
+            <a:off x="-1" y="0"/>
+            <a:ext cx="12188952" cy="6858000"/>
+          </a:xfrm>
+          <a:prstGeom prst="rect">
+            <a:avLst/>
+          </a:prstGeom>
+          <a:ln>
+            <a:noFill/>
+          </a:ln>
+        </p:spPr>
+        <p:style>
+          <a:lnRef idx="2">
+            <a:schemeClr val="accent1">
+              <a:shade val="50000"/>
+            </a:schemeClr>
+          </a:lnRef>
+          <a:fillRef idx="1">
+            <a:schemeClr val="accent1"/>
+          </a:fillRef>
+          <a:effectRef idx="0">
+            <a:schemeClr val="accent1"/>
+          </a:effectRef>
+          <a:fontRef idx="minor">
+            <a:schemeClr val="lt1"/>
+          </a:fontRef>
+        </p:style>
+        <p:txBody>
+          <a:bodyPr rtlCol="0" anchor="ctr"/>
+          <a:lstStyle/>
+          <a:p>
+            <a:pPr algn="ctr"/>
+            <a:endParaRPr lang="en-US"/>
+          </a:p>
+        </p:txBody>
+      </p:sp>
+      <p:pic>
+        <p:nvPicPr>
+          <p:cNvPr id="5" name="Immagine 4">
+            <a:extLst>
+              <a:ext uri="{FF2B5EF4-FFF2-40B4-BE49-F238E27FC236}">
+                <a16:creationId xmlns:a16="http://schemas.microsoft.com/office/drawing/2014/main" id="{4DD2D55D-857F-F874-7C99-9C8345BBEA77}"/>
+              </a:ext>
+            </a:extLst>
+          </p:cNvPr>
+          <p:cNvPicPr>
+            <a:picLocks noChangeAspect="1"/>
+          </p:cNvPicPr>
+          <p:nvPr/>
+        </p:nvPicPr>
+        <p:blipFill>
+          <a:blip r:embed="rId3"/>
+          <a:stretch>
+            <a:fillRect/>
+          </a:stretch>
+        </p:blipFill>
+        <p:spPr>
+          <a:xfrm>
+            <a:off x="434621" y="1186673"/>
+            <a:ext cx="9465131" cy="3738725"/>
+          </a:xfrm>
+          <a:prstGeom prst="rect">
+            <a:avLst/>
+          </a:prstGeom>
+        </p:spPr>
+      </p:pic>
+      <p:graphicFrame>
+        <p:nvGraphicFramePr>
+          <p:cNvPr id="6" name="Tabella 5">
+            <a:extLst>
+              <a:ext uri="{FF2B5EF4-FFF2-40B4-BE49-F238E27FC236}">
+                <a16:creationId xmlns:a16="http://schemas.microsoft.com/office/drawing/2014/main" id="{BB57905C-BD8D-3431-BA17-E7E559FFFEFC}"/>
+              </a:ext>
+            </a:extLst>
+          </p:cNvPr>
+          <p:cNvGraphicFramePr>
+            <a:graphicFrameLocks noGrp="1"/>
+          </p:cNvGraphicFramePr>
+          <p:nvPr>
+            <p:extLst>
+              <p:ext uri="{D42A27DB-BD31-4B8C-83A1-F6EECF244321}">
+                <p14:modId xmlns:p14="http://schemas.microsoft.com/office/powerpoint/2010/main" val="2481448551"/>
+              </p:ext>
+            </p:extLst>
+          </p:nvPr>
+        </p:nvGraphicFramePr>
+        <p:xfrm>
+          <a:off x="7024814" y="4539343"/>
+          <a:ext cx="5167186" cy="2196948"/>
+        </p:xfrm>
+        <a:graphic>
+          <a:graphicData uri="http://schemas.openxmlformats.org/drawingml/2006/table">
+            <a:tbl>
+              <a:tblPr firstRow="1" bandRow="1">
+                <a:tableStyleId>{5C22544A-7EE6-4342-B048-85BDC9FD1C3A}</a:tableStyleId>
+              </a:tblPr>
+              <a:tblGrid>
+                <a:gridCol w="2651813">
+                  <a:extLst>
+                    <a:ext uri="{9D8B030D-6E8A-4147-A177-3AD203B41FA5}">
+                      <a16:colId xmlns:a16="http://schemas.microsoft.com/office/drawing/2014/main" val="4019561045"/>
+                    </a:ext>
+                  </a:extLst>
+                </a:gridCol>
+                <a:gridCol w="2515373">
+                  <a:extLst>
+                    <a:ext uri="{9D8B030D-6E8A-4147-A177-3AD203B41FA5}">
+                      <a16:colId xmlns:a16="http://schemas.microsoft.com/office/drawing/2014/main" val="2982526595"/>
+                    </a:ext>
+                  </a:extLst>
+                </a:gridCol>
+              </a:tblGrid>
+              <a:tr h="310374">
+                <a:tc>
+                  <a:txBody>
+                    <a:bodyPr/>
+                    <a:lstStyle/>
+                    <a:p>
+                      <a:pPr marL="0" marR="0" algn="ctr">
+                        <a:buNone/>
+                      </a:pPr>
+                      <a:r>
+                        <a:rPr lang="it-IT" sz="1700">
+                          <a:effectLst/>
+                        </a:rPr>
+                        <a:t>Linea</a:t>
+                      </a:r>
+                      <a:endParaRPr lang="it-IT" sz="1700">
+                        <a:effectLst/>
+                        <a:latin typeface="Helvetica Neue" panose="02000503000000020004" pitchFamily="2" charset="0"/>
+                      </a:endParaRPr>
+                    </a:p>
+                  </a:txBody>
+                  <a:tcPr marL="80677" marR="80677" marT="16135" marB="16135"/>
+                </a:tc>
+                <a:tc>
+                  <a:txBody>
+                    <a:bodyPr/>
+                    <a:lstStyle/>
+                    <a:p>
+                      <a:pPr marL="0" marR="0" algn="ctr">
+                        <a:buNone/>
+                      </a:pPr>
+                      <a:r>
+                        <a:rPr lang="it-IT" sz="1700">
+                          <a:effectLst/>
+                        </a:rPr>
+                        <a:t>Significato</a:t>
+                      </a:r>
+                      <a:endParaRPr lang="it-IT" sz="1700">
+                        <a:effectLst/>
+                        <a:latin typeface="Helvetica Neue" panose="02000503000000020004" pitchFamily="2" charset="0"/>
+                      </a:endParaRPr>
+                    </a:p>
+                  </a:txBody>
+                  <a:tcPr marL="80677" marR="80677" marT="16135" marB="16135"/>
+                </a:tc>
+                <a:extLst>
+                  <a:ext uri="{0D108BD9-81ED-4DB2-BD59-A6C34878D82A}">
+                    <a16:rowId xmlns:a16="http://schemas.microsoft.com/office/drawing/2014/main" val="1856801958"/>
+                  </a:ext>
+                </a:extLst>
+              </a:tr>
+              <a:tr h="548045">
+                <a:tc>
+                  <a:txBody>
+                    <a:bodyPr/>
+                    <a:lstStyle/>
+                    <a:p>
+                      <a:pPr marL="0" marR="0">
+                        <a:buNone/>
+                      </a:pPr>
+                      <a:r>
+                        <a:rPr lang="it-IT" sz="1700">
+                          <a:effectLst/>
+                        </a:rPr>
+                        <a:t>Blu – SoC batteria</a:t>
+                      </a:r>
+                      <a:endParaRPr lang="it-IT" sz="1700">
+                        <a:effectLst/>
+                        <a:latin typeface="Helvetica Neue" panose="02000503000000020004" pitchFamily="2" charset="0"/>
+                      </a:endParaRPr>
+                    </a:p>
+                  </a:txBody>
+                  <a:tcPr marL="80677" marR="80677" marT="16135" marB="16135"/>
+                </a:tc>
+                <a:tc>
+                  <a:txBody>
+                    <a:bodyPr/>
+                    <a:lstStyle/>
+                    <a:p>
+                      <a:pPr marL="0" marR="0">
+                        <a:buNone/>
+                      </a:pPr>
+                      <a:r>
+                        <a:rPr lang="it-IT" sz="1700" dirty="0">
+                          <a:effectLst/>
+                        </a:rPr>
+                        <a:t>stato di carica della batteria (1 MWh).</a:t>
+                      </a:r>
+                      <a:endParaRPr lang="it-IT" sz="1700" dirty="0">
+                        <a:effectLst/>
+                        <a:latin typeface="Helvetica Neue" panose="02000503000000020004" pitchFamily="2" charset="0"/>
+                      </a:endParaRPr>
+                    </a:p>
+                  </a:txBody>
+                  <a:tcPr marL="80677" marR="80677" marT="16135" marB="16135"/>
+                </a:tc>
+                <a:extLst>
+                  <a:ext uri="{0D108BD9-81ED-4DB2-BD59-A6C34878D82A}">
+                    <a16:rowId xmlns:a16="http://schemas.microsoft.com/office/drawing/2014/main" val="3911515982"/>
+                  </a:ext>
+                </a:extLst>
+              </a:tr>
+              <a:tr h="548045">
+                <a:tc>
+                  <a:txBody>
+                    <a:bodyPr/>
+                    <a:lstStyle/>
+                    <a:p>
+                      <a:pPr marL="0" marR="0">
+                        <a:buNone/>
+                      </a:pPr>
+                      <a:r>
+                        <a:rPr lang="it-IT" sz="1700">
+                          <a:effectLst/>
+                        </a:rPr>
+                        <a:t>Arancione – SoH idrogeno</a:t>
+                      </a:r>
+                      <a:endParaRPr lang="it-IT" sz="1700">
+                        <a:effectLst/>
+                        <a:latin typeface="Helvetica Neue" panose="02000503000000020004" pitchFamily="2" charset="0"/>
+                      </a:endParaRPr>
+                    </a:p>
+                  </a:txBody>
+                  <a:tcPr marL="80677" marR="80677" marT="16135" marB="16135"/>
+                </a:tc>
+                <a:tc>
+                  <a:txBody>
+                    <a:bodyPr/>
+                    <a:lstStyle/>
+                    <a:p>
+                      <a:pPr marL="0" marR="0">
+                        <a:buNone/>
+                      </a:pPr>
+                      <a:r>
+                        <a:rPr lang="it-IT" sz="1700" dirty="0">
+                          <a:effectLst/>
+                        </a:rPr>
+                        <a:t>livello del serbatoio H₂ (20 MWh).</a:t>
+                      </a:r>
+                      <a:endParaRPr lang="it-IT" sz="1700" dirty="0">
+                        <a:effectLst/>
+                        <a:latin typeface="Helvetica Neue" panose="02000503000000020004" pitchFamily="2" charset="0"/>
+                      </a:endParaRPr>
+                    </a:p>
+                  </a:txBody>
+                  <a:tcPr marL="80677" marR="80677" marT="16135" marB="16135"/>
+                </a:tc>
+                <a:extLst>
+                  <a:ext uri="{0D108BD9-81ED-4DB2-BD59-A6C34878D82A}">
+                    <a16:rowId xmlns:a16="http://schemas.microsoft.com/office/drawing/2014/main" val="3453264343"/>
+                  </a:ext>
+                </a:extLst>
+              </a:tr>
+              <a:tr h="785714">
+                <a:tc>
+                  <a:txBody>
+                    <a:bodyPr/>
+                    <a:lstStyle/>
+                    <a:p>
+                      <a:pPr marL="0" marR="0">
+                        <a:buNone/>
+                      </a:pPr>
+                      <a:r>
+                        <a:rPr lang="it-IT" sz="1700">
+                          <a:effectLst/>
+                        </a:rPr>
+                        <a:t>Linee tratteggiate/punteggiate</a:t>
+                      </a:r>
+                      <a:endParaRPr lang="it-IT" sz="1700">
+                        <a:effectLst/>
+                        <a:latin typeface="Helvetica Neue" panose="02000503000000020004" pitchFamily="2" charset="0"/>
+                      </a:endParaRPr>
+                    </a:p>
+                  </a:txBody>
+                  <a:tcPr marL="80677" marR="80677" marT="16135" marB="16135"/>
+                </a:tc>
+                <a:tc>
+                  <a:txBody>
+                    <a:bodyPr/>
+                    <a:lstStyle/>
+                    <a:p>
+                      <a:pPr marL="0" marR="0">
+                        <a:buNone/>
+                      </a:pPr>
+                      <a:r>
+                        <a:rPr lang="it-IT" sz="1700" dirty="0">
+                          <a:effectLst/>
+                        </a:rPr>
+                        <a:t>limiti 10% e 90% imposti alla batteria (obiettivo c).</a:t>
+                      </a:r>
+                      <a:endParaRPr lang="it-IT" sz="1700" dirty="0">
+                        <a:effectLst/>
+                        <a:latin typeface="Helvetica Neue" panose="02000503000000020004" pitchFamily="2" charset="0"/>
+                      </a:endParaRPr>
+                    </a:p>
+                  </a:txBody>
+                  <a:tcPr marL="80677" marR="80677" marT="16135" marB="16135"/>
+                </a:tc>
+                <a:extLst>
+                  <a:ext uri="{0D108BD9-81ED-4DB2-BD59-A6C34878D82A}">
+                    <a16:rowId xmlns:a16="http://schemas.microsoft.com/office/drawing/2014/main" val="989072711"/>
+                  </a:ext>
+                </a:extLst>
+              </a:tr>
+            </a:tbl>
+          </a:graphicData>
+        </a:graphic>
+      </p:graphicFrame>
+      <p:sp>
+        <p:nvSpPr>
+          <p:cNvPr id="4" name="CasellaDiTesto 3">
+            <a:extLst>
+              <a:ext uri="{FF2B5EF4-FFF2-40B4-BE49-F238E27FC236}">
+                <a16:creationId xmlns:a16="http://schemas.microsoft.com/office/drawing/2014/main" id="{F049BE2A-C897-A78B-9ED5-AFAF53B5B956}"/>
+              </a:ext>
+            </a:extLst>
+          </p:cNvPr>
+          <p:cNvSpPr txBox="1"/>
+          <p:nvPr/>
+        </p:nvSpPr>
+        <p:spPr>
+          <a:xfrm>
+            <a:off x="434621" y="316338"/>
+            <a:ext cx="6115050" cy="553998"/>
+          </a:xfrm>
+          <a:prstGeom prst="rect">
+            <a:avLst/>
+          </a:prstGeom>
+          <a:noFill/>
+        </p:spPr>
+        <p:txBody>
+          <a:bodyPr wrap="square">
+            <a:spAutoFit/>
+          </a:bodyPr>
+          <a:lstStyle/>
+          <a:p>
+            <a:r>
+              <a:rPr lang="it-IT" sz="3000" b="1" dirty="0">
+                <a:solidFill>
+                  <a:srgbClr val="0B3D59"/>
+                </a:solidFill>
+                <a:latin typeface="Cambria" pitchFamily="34" charset="0"/>
+              </a:rPr>
+              <a:t>Livello degli accumuli</a:t>
+            </a:r>
+          </a:p>
+        </p:txBody>
+      </p:sp>
+    </p:spTree>
+    <p:extLst>
+      <p:ext uri="{BB962C8B-B14F-4D97-AF65-F5344CB8AC3E}">
+        <p14:creationId xmlns:p14="http://schemas.microsoft.com/office/powerpoint/2010/main" val="2253709382"/>
+      </p:ext>
+    </p:extLst>
+  </p:cSld>
+  <p:clrMapOvr>
+    <a:masterClrMapping/>
+  </p:clrMapOvr>
+</p:sld>
+</file>
+
+<file path=ppt/slides/slide18.xml><?xml version="1.0" encoding="utf-8"?>
 <p:sld xmlns:a="http://schemas.openxmlformats.org/drawingml/2006/main" xmlns:r="http://schemas.openxmlformats.org/officeDocument/2006/relationships" xmlns:p="http://schemas.openxmlformats.org/presentationml/2006/main">
   <p:cSld name="Slide 17">
     <p:bg>
@@ -7130,45 +8754,6 @@
           </a:p>
         </p:txBody>
       </p:sp>
-      <p:sp>
-        <p:nvSpPr>
-          <p:cNvPr id="12" name="Text 9"/>
-          <p:cNvSpPr/>
-          <p:nvPr/>
-        </p:nvSpPr>
-        <p:spPr>
-          <a:xfrm>
-            <a:off x="11094415" y="6473952"/>
-            <a:ext cx="548640" cy="274320"/>
-          </a:xfrm>
-          <a:prstGeom prst="rect">
-            <a:avLst/>
-          </a:prstGeom>
-          <a:noFill/>
-          <a:ln/>
-        </p:spPr>
-        <p:txBody>
-          <a:bodyPr wrap="square" lIns="0" tIns="0" rIns="0" bIns="0" rtlCol="0" anchor="ctr"/>
-          <a:lstStyle/>
-          <a:p>
-            <a:pPr marL="0" indent="0" algn="r">
-              <a:buNone/>
-            </a:pPr>
-            <a:r>
-              <a:rPr lang="en-US" sz="900" dirty="0">
-                <a:solidFill>
-                  <a:srgbClr val="6B7A85"/>
-                </a:solidFill>
-                <a:latin typeface="Calibri" pitchFamily="34" charset="0"/>
-                <a:ea typeface="Calibri" pitchFamily="34" charset="-122"/>
-                <a:cs typeface="Calibri" pitchFamily="34" charset="-120"/>
-              </a:rPr>
-              <a:t>16</a:t>
-            </a:r>
-            <a:endParaRPr lang="en-US" sz="900" dirty="0"/>
-          </a:p>
-        </p:txBody>
-      </p:sp>
     </p:spTree>
   </p:cSld>
   <p:clrMapOvr>
@@ -7177,7 +8762,7 @@
 </p:sld>
 </file>
 
-<file path=ppt/slides/slide16.xml><?xml version="1.0" encoding="utf-8"?>
+<file path=ppt/slides/slide19.xml><?xml version="1.0" encoding="utf-8"?>
 <p:sld xmlns:a="http://schemas.openxmlformats.org/drawingml/2006/main" xmlns:r="http://schemas.openxmlformats.org/officeDocument/2006/relationships" xmlns:p="http://schemas.openxmlformats.org/presentationml/2006/main">
   <p:cSld name="Slide 18">
     <p:bg>
@@ -7356,144 +8941,6 @@
               <a:t>Il curtailment si osserva solo in un test sintetico dedicato (ultimo_test.py), costruito apposta con accumuli pieni e produzione rinnovabile molto più alta del carico.</a:t>
             </a:r>
             <a:endParaRPr lang="en-US" sz="1550" dirty="0"/>
-          </a:p>
-        </p:txBody>
-      </p:sp>
-      <p:sp>
-        <p:nvSpPr>
-          <p:cNvPr id="9" name="Text 7"/>
-          <p:cNvSpPr/>
-          <p:nvPr/>
-        </p:nvSpPr>
-        <p:spPr>
-          <a:xfrm>
-            <a:off x="11094415" y="6473952"/>
-            <a:ext cx="548640" cy="274320"/>
-          </a:xfrm>
-          <a:prstGeom prst="rect">
-            <a:avLst/>
-          </a:prstGeom>
-          <a:noFill/>
-          <a:ln/>
-        </p:spPr>
-        <p:txBody>
-          <a:bodyPr wrap="square" lIns="0" tIns="0" rIns="0" bIns="0" rtlCol="0" anchor="ctr"/>
-          <a:lstStyle/>
-          <a:p>
-            <a:pPr marL="0" indent="0" algn="r">
-              <a:buNone/>
-            </a:pPr>
-            <a:r>
-              <a:rPr lang="en-US" sz="900" dirty="0">
-                <a:solidFill>
-                  <a:srgbClr val="6B7A85"/>
-                </a:solidFill>
-                <a:latin typeface="Calibri" pitchFamily="34" charset="0"/>
-                <a:ea typeface="Calibri" pitchFamily="34" charset="-122"/>
-                <a:cs typeface="Calibri" pitchFamily="34" charset="-120"/>
-              </a:rPr>
-              <a:t>17</a:t>
-            </a:r>
-            <a:endParaRPr lang="en-US" sz="900" dirty="0"/>
-          </a:p>
-        </p:txBody>
-      </p:sp>
-    </p:spTree>
-  </p:cSld>
-  <p:clrMapOvr>
-    <a:masterClrMapping/>
-  </p:clrMapOvr>
-</p:sld>
-</file>
-
-<file path=ppt/slides/slide17.xml><?xml version="1.0" encoding="utf-8"?>
-<p:sld xmlns:a="http://schemas.openxmlformats.org/drawingml/2006/main" xmlns:r="http://schemas.openxmlformats.org/officeDocument/2006/relationships" xmlns:p="http://schemas.openxmlformats.org/presentationml/2006/main">
-  <p:cSld name="Slide 20">
-    <p:bg>
-      <p:bgPr>
-        <a:solidFill>
-          <a:srgbClr val="0B3D59"/>
-        </a:solidFill>
-        <a:effectLst/>
-      </p:bgPr>
-    </p:bg>
-    <p:spTree>
-      <p:nvGrpSpPr>
-        <p:cNvPr id="1" name=""/>
-        <p:cNvGrpSpPr/>
-        <p:nvPr/>
-      </p:nvGrpSpPr>
-      <p:grpSpPr>
-        <a:xfrm>
-          <a:off x="0" y="0"/>
-          <a:ext cx="0" cy="0"/>
-          <a:chOff x="0" y="0"/>
-          <a:chExt cx="0" cy="0"/>
-        </a:xfrm>
-      </p:grpSpPr>
-      <p:sp>
-        <p:nvSpPr>
-          <p:cNvPr id="2" name="Shape 0"/>
-          <p:cNvSpPr/>
-          <p:nvPr/>
-        </p:nvSpPr>
-        <p:spPr>
-          <a:xfrm>
-            <a:off x="-1645920" y="3931920"/>
-            <a:ext cx="4572000" cy="4572000"/>
-          </a:xfrm>
-          <a:prstGeom prst="ellipse">
-            <a:avLst/>
-          </a:prstGeom>
-          <a:solidFill>
-            <a:srgbClr val="082B40"/>
-          </a:solidFill>
-          <a:ln/>
-        </p:spPr>
-        <p:txBody>
-          <a:bodyPr/>
-          <a:lstStyle/>
-          <a:p>
-            <a:endParaRPr lang="it-IT"/>
-          </a:p>
-        </p:txBody>
-      </p:sp>
-      <p:sp>
-        <p:nvSpPr>
-          <p:cNvPr id="5" name="Text 3"/>
-          <p:cNvSpPr/>
-          <p:nvPr/>
-        </p:nvSpPr>
-        <p:spPr>
-          <a:xfrm>
-            <a:off x="548640" y="2743200"/>
-            <a:ext cx="11094415" cy="914400"/>
-          </a:xfrm>
-          <a:prstGeom prst="rect">
-            <a:avLst/>
-          </a:prstGeom>
-          <a:noFill/>
-          <a:ln/>
-        </p:spPr>
-        <p:txBody>
-          <a:bodyPr wrap="square" lIns="0" tIns="0" rIns="0" bIns="0" rtlCol="0" anchor="ctr"/>
-          <a:lstStyle/>
-          <a:p>
-            <a:pPr marL="0" indent="0">
-              <a:buNone/>
-            </a:pPr>
-            <a:r>
-              <a:rPr lang="en-US" sz="3800" b="1" dirty="0">
-                <a:solidFill>
-                  <a:srgbClr val="FFFFFF"/>
-                </a:solidFill>
-                <a:latin typeface="Cambria" pitchFamily="34" charset="0"/>
-                <a:ea typeface="Cambria" pitchFamily="34" charset="-122"/>
-                <a:cs typeface="Cambria" pitchFamily="34" charset="-120"/>
-              </a:rPr>
-              <a:t>Grazie per l'attenzione</a:t>
-            </a:r>
-            <a:endParaRPr lang="en-US" sz="3800" dirty="0"/>
           </a:p>
         </p:txBody>
       </p:sp>
@@ -8199,6 +9646,105 @@
               <a:t>Minimizzare lo spreco di rinnovabile</a:t>
             </a:r>
             <a:endParaRPr lang="en-US" sz="1300" dirty="0"/>
+          </a:p>
+        </p:txBody>
+      </p:sp>
+    </p:spTree>
+  </p:cSld>
+  <p:clrMapOvr>
+    <a:masterClrMapping/>
+  </p:clrMapOvr>
+</p:sld>
+</file>
+
+<file path=ppt/slides/slide20.xml><?xml version="1.0" encoding="utf-8"?>
+<p:sld xmlns:a="http://schemas.openxmlformats.org/drawingml/2006/main" xmlns:r="http://schemas.openxmlformats.org/officeDocument/2006/relationships" xmlns:p="http://schemas.openxmlformats.org/presentationml/2006/main">
+  <p:cSld name="Slide 20">
+    <p:bg>
+      <p:bgPr>
+        <a:solidFill>
+          <a:srgbClr val="0B3D59"/>
+        </a:solidFill>
+        <a:effectLst/>
+      </p:bgPr>
+    </p:bg>
+    <p:spTree>
+      <p:nvGrpSpPr>
+        <p:cNvPr id="1" name=""/>
+        <p:cNvGrpSpPr/>
+        <p:nvPr/>
+      </p:nvGrpSpPr>
+      <p:grpSpPr>
+        <a:xfrm>
+          <a:off x="0" y="0"/>
+          <a:ext cx="0" cy="0"/>
+          <a:chOff x="0" y="0"/>
+          <a:chExt cx="0" cy="0"/>
+        </a:xfrm>
+      </p:grpSpPr>
+      <p:sp>
+        <p:nvSpPr>
+          <p:cNvPr id="2" name="Shape 0"/>
+          <p:cNvSpPr/>
+          <p:nvPr/>
+        </p:nvSpPr>
+        <p:spPr>
+          <a:xfrm>
+            <a:off x="-1645920" y="3931920"/>
+            <a:ext cx="4572000" cy="4572000"/>
+          </a:xfrm>
+          <a:prstGeom prst="ellipse">
+            <a:avLst/>
+          </a:prstGeom>
+          <a:solidFill>
+            <a:srgbClr val="082B40"/>
+          </a:solidFill>
+          <a:ln/>
+        </p:spPr>
+        <p:txBody>
+          <a:bodyPr/>
+          <a:lstStyle/>
+          <a:p>
+            <a:endParaRPr lang="it-IT"/>
+          </a:p>
+        </p:txBody>
+      </p:sp>
+      <p:sp>
+        <p:nvSpPr>
+          <p:cNvPr id="5" name="Text 3"/>
+          <p:cNvSpPr/>
+          <p:nvPr/>
+        </p:nvSpPr>
+        <p:spPr>
+          <a:xfrm>
+            <a:off x="548640" y="2743200"/>
+            <a:ext cx="11094415" cy="914400"/>
+          </a:xfrm>
+          <a:prstGeom prst="rect">
+            <a:avLst/>
+          </a:prstGeom>
+          <a:noFill/>
+          <a:ln/>
+        </p:spPr>
+        <p:txBody>
+          <a:bodyPr wrap="square" lIns="0" tIns="0" rIns="0" bIns="0" rtlCol="0" anchor="ctr"/>
+          <a:lstStyle/>
+          <a:p>
+            <a:pPr marL="0" indent="0">
+              <a:buNone/>
+            </a:pPr>
+            <a:r>
+              <a:rPr lang="en-US" sz="3800" b="1" dirty="0">
+                <a:solidFill>
+                  <a:srgbClr val="FFFFFF"/>
+                </a:solidFill>
+                <a:latin typeface="Cambria" pitchFamily="34" charset="0"/>
+                <a:ea typeface="Cambria" pitchFamily="34" charset="-122"/>
+                <a:cs typeface="Cambria" pitchFamily="34" charset="-120"/>
+              </a:rPr>
+              <a:t>Grazie per l'attenzione</a:t>
+            </a:r>
+            <a:endParaRPr lang="en-US" sz="3800" dirty="0"/>
           </a:p>
         </p:txBody>
       </p:sp>
@@ -12757,45 +14303,6 @@
               <a:t>+ Carica della batteria</a:t>
             </a:r>
             <a:endParaRPr lang="en-US" sz="1350" dirty="0"/>
-          </a:p>
-        </p:txBody>
-      </p:sp>
-      <p:sp>
-        <p:nvSpPr>
-          <p:cNvPr id="21" name="Text 19"/>
-          <p:cNvSpPr/>
-          <p:nvPr/>
-        </p:nvSpPr>
-        <p:spPr>
-          <a:xfrm>
-            <a:off x="11094415" y="6473952"/>
-            <a:ext cx="548640" cy="274320"/>
-          </a:xfrm>
-          <a:prstGeom prst="rect">
-            <a:avLst/>
-          </a:prstGeom>
-          <a:noFill/>
-          <a:ln/>
-        </p:spPr>
-        <p:txBody>
-          <a:bodyPr wrap="square" lIns="0" tIns="0" rIns="0" bIns="0" rtlCol="0" anchor="ctr"/>
-          <a:lstStyle/>
-          <a:p>
-            <a:pPr marL="0" indent="0" algn="r">
-              <a:buNone/>
-            </a:pPr>
-            <a:r>
-              <a:rPr lang="en-US" sz="900" dirty="0">
-                <a:solidFill>
-                  <a:srgbClr val="6B7A85"/>
-                </a:solidFill>
-                <a:latin typeface="Calibri" pitchFamily="34" charset="0"/>
-                <a:ea typeface="Calibri" pitchFamily="34" charset="-122"/>
-                <a:cs typeface="Calibri" pitchFamily="34" charset="-120"/>
-              </a:rPr>
-              <a:t>9</a:t>
-            </a:r>
-            <a:endParaRPr lang="en-US" sz="900" dirty="0"/>
           </a:p>
         </p:txBody>
       </p:sp>

</xml_diff>